<commit_message>
Update PPT presentation background theme to pure cyan (#00FFFF) with high-contrast typography
</commit_message>
<xml_diff>
--- a/Textract_iQOO_Hackathon_2026.pptx
+++ b/Textract_iQOO_Hackathon_2026.pptx
@@ -3114,7 +3114,7 @@
             <a:avLst/>
           </a:prstGeom>
           <a:solidFill>
-            <a:srgbClr val="0B111E"/>
+            <a:srgbClr val="00FFFF"/>
           </a:solidFill>
           <a:ln>
             <a:noFill/>
@@ -3151,13 +3151,13 @@
         <p:spPr>
           <a:xfrm>
             <a:off x="0" y="0"/>
-            <a:ext cx="12191695" cy="54864"/>
+            <a:ext cx="12191695" cy="64008"/>
           </a:xfrm>
           <a:prstGeom prst="rect">
             <a:avLst/>
           </a:prstGeom>
           <a:solidFill>
-            <a:srgbClr val="90E6FC"/>
+            <a:srgbClr val="061830"/>
           </a:solidFill>
           <a:ln>
             <a:noFill/>
@@ -3200,11 +3200,11 @@
             <a:avLst/>
           </a:prstGeom>
           <a:solidFill>
-            <a:srgbClr val="0E1727"/>
+            <a:srgbClr val="FFFFFF"/>
           </a:solidFill>
           <a:ln w="15240">
             <a:solidFill>
-              <a:srgbClr val="2D5F82"/>
+              <a:srgbClr val="061830"/>
             </a:solidFill>
           </a:ln>
         </p:spPr>
@@ -3238,18 +3238,18 @@
         </p:nvSpPr>
         <p:spPr>
           <a:xfrm>
-            <a:off x="1188720" y="1143000"/>
-            <a:ext cx="3840480" cy="384048"/>
+            <a:off x="1188720" y="1097280"/>
+            <a:ext cx="3931920" cy="384048"/>
           </a:xfrm>
           <a:prstGeom prst="roundRect">
             <a:avLst/>
           </a:prstGeom>
           <a:solidFill>
-            <a:srgbClr val="102A41"/>
+            <a:srgbClr val="061830"/>
           </a:solidFill>
           <a:ln w="12700">
             <a:solidFill>
-              <a:srgbClr val="90E6FC"/>
+              <a:srgbClr val="061830"/>
             </a:solidFill>
           </a:ln>
         </p:spPr>
@@ -3274,7 +3274,7 @@
             <a:pPr algn="ctr">
               <a:defRPr sz="1100" b="1">
                 <a:solidFill>
-                  <a:srgbClr val="90E6FC"/>
+                  <a:srgbClr val="00FFFF"/>
                 </a:solidFill>
                 <a:latin typeface="Segoe UI"/>
               </a:defRPr>
@@ -3293,8 +3293,8 @@
         </p:nvSpPr>
         <p:spPr>
           <a:xfrm>
-            <a:off x="1188720" y="1737360"/>
-            <a:ext cx="9784080" cy="2103120"/>
+            <a:off x="1188720" y="1691640"/>
+            <a:ext cx="9784080" cy="2148840"/>
           </a:xfrm>
           <a:prstGeom prst="rect">
             <a:avLst/>
@@ -3309,11 +3309,11 @@
           <a:p>
             <a:pPr>
               <a:spcAft>
-                <a:spcPts val="400"/>
+                <a:spcPts val="300"/>
               </a:spcAft>
               <a:defRPr sz="5000" b="1">
                 <a:solidFill>
-                  <a:srgbClr val="90E6FC"/>
+                  <a:srgbClr val="061830"/>
                 </a:solidFill>
                 <a:latin typeface="Segoe UI"/>
               </a:defRPr>
@@ -3325,11 +3325,11 @@
           <a:p>
             <a:pPr>
               <a:spcAft>
-                <a:spcPts val="1000"/>
+                <a:spcPts val="800"/>
               </a:spcAft>
               <a:defRPr sz="2200" b="1">
                 <a:solidFill>
-                  <a:srgbClr val="FFFFFF"/>
+                  <a:srgbClr val="004BA5"/>
                 </a:solidFill>
                 <a:latin typeface="Segoe UI"/>
               </a:defRPr>
@@ -3342,7 +3342,7 @@
             <a:pPr>
               <a:defRPr sz="1350">
                 <a:solidFill>
-                  <a:srgbClr val="94A3B8"/>
+                  <a:srgbClr val="142438"/>
                 </a:solidFill>
                 <a:latin typeface="Segoe UI"/>
               </a:defRPr>
@@ -3366,17 +3366,17 @@
         <p:spPr>
           <a:xfrm>
             <a:off x="1188720" y="4114800"/>
-            <a:ext cx="4754880" cy="1645920"/>
+            <a:ext cx="4754880" cy="1691640"/>
           </a:xfrm>
           <a:prstGeom prst="roundRect">
             <a:avLst/>
           </a:prstGeom>
           <a:solidFill>
-            <a:srgbClr val="142036"/>
+            <a:srgbClr val="C6F5FF"/>
           </a:solidFill>
           <a:ln w="15240">
             <a:solidFill>
-              <a:srgbClr val="90E6FC"/>
+              <a:srgbClr val="061830"/>
             </a:solidFill>
           </a:ln>
         </p:spPr>
@@ -3395,7 +3395,7 @@
           </a:fontRef>
         </p:style>
         <p:txBody>
-          <a:bodyPr rtlCol="0" anchor="ctr" wrap="square" lIns="228600" tIns="182880"/>
+          <a:bodyPr rtlCol="0" anchor="ctr" wrap="square" lIns="228600" tIns="164592"/>
           <a:lstStyle/>
           <a:p>
             <a:pPr algn="ctr">
@@ -3404,7 +3404,7 @@
               </a:spcAft>
               <a:defRPr sz="1000" b="1">
                 <a:solidFill>
-                  <a:srgbClr val="90E6FC"/>
+                  <a:srgbClr val="004BA5"/>
                 </a:solidFill>
                 <a:latin typeface="Segoe UI"/>
               </a:defRPr>
@@ -3417,7 +3417,7 @@
             <a:pPr>
               <a:defRPr sz="1500" b="1">
                 <a:solidFill>
-                  <a:srgbClr val="FFFFFF"/>
+                  <a:srgbClr val="061830"/>
                 </a:solidFill>
                 <a:latin typeface="Segoe UI"/>
               </a:defRPr>
@@ -3429,11 +3429,11 @@
           <a:p>
             <a:pPr>
               <a:spcAft>
-                <a:spcPts val="400"/>
+                <a:spcPts val="300"/>
               </a:spcAft>
               <a:defRPr sz="1500" b="1">
                 <a:solidFill>
-                  <a:srgbClr val="FFFFFF"/>
+                  <a:srgbClr val="061830"/>
                 </a:solidFill>
                 <a:latin typeface="Segoe UI"/>
               </a:defRPr>
@@ -3446,7 +3446,7 @@
             <a:pPr>
               <a:defRPr sz="950">
                 <a:solidFill>
-                  <a:srgbClr val="50B4D7"/>
+                  <a:srgbClr val="344862"/>
                 </a:solidFill>
                 <a:latin typeface="Segoe UI"/>
               </a:defRPr>
@@ -3466,17 +3466,17 @@
         <p:spPr>
           <a:xfrm>
             <a:off x="6217920" y="4114800"/>
-            <a:ext cx="4754880" cy="347472"/>
+            <a:ext cx="4754880" cy="356616"/>
           </a:xfrm>
           <a:prstGeom prst="roundRect">
             <a:avLst/>
           </a:prstGeom>
           <a:solidFill>
-            <a:srgbClr val="101A2C"/>
+            <a:srgbClr val="E4FCFF"/>
           </a:solidFill>
           <a:ln w="15240">
             <a:solidFill>
-              <a:srgbClr val="20304C"/>
+              <a:srgbClr val="1E5082"/>
             </a:solidFill>
           </a:ln>
         </p:spPr>
@@ -3495,13 +3495,13 @@
           </a:fontRef>
         </p:style>
         <p:txBody>
-          <a:bodyPr rtlCol="0" anchor="ctr" wrap="square" lIns="137160" tIns="54864"/>
+          <a:bodyPr rtlCol="0" anchor="ctr" wrap="square" lIns="164592" tIns="54864"/>
           <a:lstStyle/>
           <a:p>
             <a:pPr algn="ctr">
-              <a:defRPr sz="1000">
-                <a:solidFill>
-                  <a:srgbClr val="BEF3FE"/>
+              <a:defRPr sz="1000" b="1">
+                <a:solidFill>
+                  <a:srgbClr val="061830"/>
                 </a:solidFill>
                 <a:latin typeface="Segoe UI"/>
               </a:defRPr>
@@ -3520,18 +3520,18 @@
         </p:nvSpPr>
         <p:spPr>
           <a:xfrm>
-            <a:off x="6217920" y="4517136"/>
-            <a:ext cx="4754880" cy="347472"/>
+            <a:off x="6217920" y="4526280"/>
+            <a:ext cx="4754880" cy="356616"/>
           </a:xfrm>
           <a:prstGeom prst="roundRect">
             <a:avLst/>
           </a:prstGeom>
           <a:solidFill>
-            <a:srgbClr val="101A2C"/>
+            <a:srgbClr val="E4FCFF"/>
           </a:solidFill>
           <a:ln w="15240">
             <a:solidFill>
-              <a:srgbClr val="20304C"/>
+              <a:srgbClr val="1E5082"/>
             </a:solidFill>
           </a:ln>
         </p:spPr>
@@ -3550,13 +3550,13 @@
           </a:fontRef>
         </p:style>
         <p:txBody>
-          <a:bodyPr rtlCol="0" anchor="ctr" wrap="square" lIns="137160" tIns="54864"/>
+          <a:bodyPr rtlCol="0" anchor="ctr" wrap="square" lIns="164592" tIns="54864"/>
           <a:lstStyle/>
           <a:p>
             <a:pPr algn="ctr">
-              <a:defRPr sz="1000">
-                <a:solidFill>
-                  <a:srgbClr val="BEF3FE"/>
+              <a:defRPr sz="1000" b="1">
+                <a:solidFill>
+                  <a:srgbClr val="061830"/>
                 </a:solidFill>
                 <a:latin typeface="Segoe UI"/>
               </a:defRPr>
@@ -3575,18 +3575,18 @@
         </p:nvSpPr>
         <p:spPr>
           <a:xfrm>
-            <a:off x="6217920" y="4919472"/>
-            <a:ext cx="4754880" cy="347472"/>
+            <a:off x="6217920" y="4937760"/>
+            <a:ext cx="4754880" cy="356616"/>
           </a:xfrm>
           <a:prstGeom prst="roundRect">
             <a:avLst/>
           </a:prstGeom>
           <a:solidFill>
-            <a:srgbClr val="101A2C"/>
+            <a:srgbClr val="E4FCFF"/>
           </a:solidFill>
           <a:ln w="15240">
             <a:solidFill>
-              <a:srgbClr val="20304C"/>
+              <a:srgbClr val="1E5082"/>
             </a:solidFill>
           </a:ln>
         </p:spPr>
@@ -3605,13 +3605,13 @@
           </a:fontRef>
         </p:style>
         <p:txBody>
-          <a:bodyPr rtlCol="0" anchor="ctr" wrap="square" lIns="137160" tIns="54864"/>
+          <a:bodyPr rtlCol="0" anchor="ctr" wrap="square" lIns="164592" tIns="54864"/>
           <a:lstStyle/>
           <a:p>
             <a:pPr algn="ctr">
-              <a:defRPr sz="1000">
-                <a:solidFill>
-                  <a:srgbClr val="BEF3FE"/>
+              <a:defRPr sz="1000" b="1">
+                <a:solidFill>
+                  <a:srgbClr val="061830"/>
                 </a:solidFill>
                 <a:latin typeface="Segoe UI"/>
               </a:defRPr>
@@ -3630,18 +3630,18 @@
         </p:nvSpPr>
         <p:spPr>
           <a:xfrm>
-            <a:off x="6217920" y="5321808"/>
-            <a:ext cx="4754880" cy="347472"/>
+            <a:off x="6217920" y="5349240"/>
+            <a:ext cx="4754880" cy="356616"/>
           </a:xfrm>
           <a:prstGeom prst="roundRect">
             <a:avLst/>
           </a:prstGeom>
           <a:solidFill>
-            <a:srgbClr val="101A2C"/>
+            <a:srgbClr val="E4FCFF"/>
           </a:solidFill>
           <a:ln w="15240">
             <a:solidFill>
-              <a:srgbClr val="20304C"/>
+              <a:srgbClr val="1E5082"/>
             </a:solidFill>
           </a:ln>
         </p:spPr>
@@ -3660,13 +3660,13 @@
           </a:fontRef>
         </p:style>
         <p:txBody>
-          <a:bodyPr rtlCol="0" anchor="ctr" wrap="square" lIns="137160" tIns="54864"/>
+          <a:bodyPr rtlCol="0" anchor="ctr" wrap="square" lIns="164592" tIns="54864"/>
           <a:lstStyle/>
           <a:p>
             <a:pPr algn="ctr">
-              <a:defRPr sz="1000">
-                <a:solidFill>
-                  <a:srgbClr val="BEF3FE"/>
+              <a:defRPr sz="1000" b="1">
+                <a:solidFill>
+                  <a:srgbClr val="061830"/>
                 </a:solidFill>
                 <a:latin typeface="Segoe UI"/>
               </a:defRPr>
@@ -3710,7 +3710,7 @@
             <a:avLst/>
           </a:prstGeom>
           <a:solidFill>
-            <a:srgbClr val="0B111E"/>
+            <a:srgbClr val="00FFFF"/>
           </a:solidFill>
           <a:ln>
             <a:noFill/>
@@ -3747,13 +3747,13 @@
         <p:spPr>
           <a:xfrm>
             <a:off x="0" y="0"/>
-            <a:ext cx="12191695" cy="54864"/>
+            <a:ext cx="12191695" cy="64008"/>
           </a:xfrm>
           <a:prstGeom prst="rect">
             <a:avLst/>
           </a:prstGeom>
           <a:solidFill>
-            <a:srgbClr val="90E6FC"/>
+            <a:srgbClr val="061830"/>
           </a:solidFill>
           <a:ln>
             <a:noFill/>
@@ -3790,7 +3790,7 @@
         <p:spPr>
           <a:xfrm>
             <a:off x="731520" y="320040"/>
-            <a:ext cx="10728655" cy="1005840"/>
+            <a:ext cx="10728655" cy="1051560"/>
           </a:xfrm>
           <a:prstGeom prst="rect">
             <a:avLst/>
@@ -3807,9 +3807,9 @@
               <a:spcAft>
                 <a:spcPts val="200"/>
               </a:spcAft>
-              <a:defRPr sz="1050" b="1">
-                <a:solidFill>
-                  <a:srgbClr val="90E6FC"/>
+              <a:defRPr sz="1100" b="1">
+                <a:solidFill>
+                  <a:srgbClr val="004BA5"/>
                 </a:solidFill>
                 <a:latin typeface="Segoe UI"/>
               </a:defRPr>
@@ -3825,7 +3825,7 @@
               </a:spcAft>
               <a:defRPr sz="2200" b="1">
                 <a:solidFill>
-                  <a:srgbClr val="FFFFFF"/>
+                  <a:srgbClr val="061830"/>
                 </a:solidFill>
                 <a:latin typeface="Segoe UI"/>
               </a:defRPr>
@@ -3838,7 +3838,7 @@
             <a:pPr>
               <a:defRPr sz="1200">
                 <a:solidFill>
-                  <a:srgbClr val="94A3B8"/>
+                  <a:srgbClr val="142438"/>
                 </a:solidFill>
                 <a:latin typeface="Segoe UI"/>
               </a:defRPr>
@@ -3864,11 +3864,11 @@
             <a:avLst/>
           </a:prstGeom>
           <a:solidFill>
-            <a:srgbClr val="131E32"/>
+            <a:srgbClr val="FFFFFF"/>
           </a:solidFill>
           <a:ln w="15240">
             <a:solidFill>
-              <a:srgbClr val="20304C"/>
+              <a:srgbClr val="08264B"/>
             </a:solidFill>
           </a:ln>
         </p:spPr>
@@ -3896,7 +3896,7 @@
               </a:spcAft>
               <a:defRPr sz="1700" b="1">
                 <a:solidFill>
-                  <a:srgbClr val="90E6FC"/>
+                  <a:srgbClr val="004BA5"/>
                 </a:solidFill>
                 <a:latin typeface="Segoe UI"/>
               </a:defRPr>
@@ -3909,7 +3909,7 @@
             <a:pPr>
               <a:defRPr sz="1300">
                 <a:solidFill>
-                  <a:srgbClr val="94A3B8"/>
+                  <a:srgbClr val="142438"/>
                 </a:solidFill>
                 <a:latin typeface="Segoe UI"/>
               </a:defRPr>
@@ -3939,11 +3939,11 @@
             <a:avLst/>
           </a:prstGeom>
           <a:solidFill>
-            <a:srgbClr val="131E32"/>
+            <a:srgbClr val="FFFFFF"/>
           </a:solidFill>
           <a:ln w="15240">
             <a:solidFill>
-              <a:srgbClr val="20304C"/>
+              <a:srgbClr val="08264B"/>
             </a:solidFill>
           </a:ln>
         </p:spPr>
@@ -3971,7 +3971,7 @@
               </a:spcAft>
               <a:defRPr sz="1700" b="1">
                 <a:solidFill>
-                  <a:srgbClr val="90E6FC"/>
+                  <a:srgbClr val="004BA5"/>
                 </a:solidFill>
                 <a:latin typeface="Segoe UI"/>
               </a:defRPr>
@@ -3984,7 +3984,7 @@
             <a:pPr>
               <a:defRPr sz="1300">
                 <a:solidFill>
-                  <a:srgbClr val="94A3B8"/>
+                  <a:srgbClr val="142438"/>
                 </a:solidFill>
                 <a:latin typeface="Segoe UI"/>
               </a:defRPr>
@@ -4014,11 +4014,11 @@
             <a:avLst/>
           </a:prstGeom>
           <a:solidFill>
-            <a:srgbClr val="131E32"/>
+            <a:srgbClr val="FFFFFF"/>
           </a:solidFill>
           <a:ln w="15240">
             <a:solidFill>
-              <a:srgbClr val="20304C"/>
+              <a:srgbClr val="08264B"/>
             </a:solidFill>
           </a:ln>
         </p:spPr>
@@ -4046,7 +4046,7 @@
               </a:spcAft>
               <a:defRPr sz="1700" b="1">
                 <a:solidFill>
-                  <a:srgbClr val="90E6FC"/>
+                  <a:srgbClr val="004BA5"/>
                 </a:solidFill>
                 <a:latin typeface="Segoe UI"/>
               </a:defRPr>
@@ -4059,7 +4059,7 @@
             <a:pPr>
               <a:defRPr sz="1300">
                 <a:solidFill>
-                  <a:srgbClr val="94A3B8"/>
+                  <a:srgbClr val="142438"/>
                 </a:solidFill>
                 <a:latin typeface="Segoe UI"/>
               </a:defRPr>
@@ -4107,7 +4107,7 @@
             <a:avLst/>
           </a:prstGeom>
           <a:solidFill>
-            <a:srgbClr val="0B111E"/>
+            <a:srgbClr val="00FFFF"/>
           </a:solidFill>
           <a:ln>
             <a:noFill/>
@@ -4144,13 +4144,13 @@
         <p:spPr>
           <a:xfrm>
             <a:off x="0" y="0"/>
-            <a:ext cx="12191695" cy="54864"/>
+            <a:ext cx="12191695" cy="64008"/>
           </a:xfrm>
           <a:prstGeom prst="rect">
             <a:avLst/>
           </a:prstGeom>
           <a:solidFill>
-            <a:srgbClr val="90E6FC"/>
+            <a:srgbClr val="061830"/>
           </a:solidFill>
           <a:ln>
             <a:noFill/>
@@ -4187,7 +4187,7 @@
         <p:spPr>
           <a:xfrm>
             <a:off x="731520" y="320040"/>
-            <a:ext cx="10728655" cy="1005840"/>
+            <a:ext cx="10728655" cy="1051560"/>
           </a:xfrm>
           <a:prstGeom prst="rect">
             <a:avLst/>
@@ -4204,9 +4204,9 @@
               <a:spcAft>
                 <a:spcPts val="200"/>
               </a:spcAft>
-              <a:defRPr sz="1050" b="1">
-                <a:solidFill>
-                  <a:srgbClr val="90E6FC"/>
+              <a:defRPr sz="1100" b="1">
+                <a:solidFill>
+                  <a:srgbClr val="004BA5"/>
                 </a:solidFill>
                 <a:latin typeface="Segoe UI"/>
               </a:defRPr>
@@ -4222,7 +4222,7 @@
               </a:spcAft>
               <a:defRPr sz="2200" b="1">
                 <a:solidFill>
-                  <a:srgbClr val="FFFFFF"/>
+                  <a:srgbClr val="061830"/>
                 </a:solidFill>
                 <a:latin typeface="Segoe UI"/>
               </a:defRPr>
@@ -4235,7 +4235,7 @@
             <a:pPr>
               <a:defRPr sz="1200">
                 <a:solidFill>
-                  <a:srgbClr val="94A3B8"/>
+                  <a:srgbClr val="142438"/>
                 </a:solidFill>
                 <a:latin typeface="Segoe UI"/>
               </a:defRPr>
@@ -4261,11 +4261,11 @@
             <a:avLst/>
           </a:prstGeom>
           <a:solidFill>
-            <a:srgbClr val="131E32"/>
+            <a:srgbClr val="FFFFFF"/>
           </a:solidFill>
           <a:ln w="15240">
             <a:solidFill>
-              <a:srgbClr val="20304C"/>
+              <a:srgbClr val="08264B"/>
             </a:solidFill>
           </a:ln>
         </p:spPr>
@@ -4293,7 +4293,7 @@
               </a:spcAft>
               <a:defRPr sz="1700" b="1">
                 <a:solidFill>
-                  <a:srgbClr val="90E6FC"/>
+                  <a:srgbClr val="004BA5"/>
                 </a:solidFill>
                 <a:latin typeface="Segoe UI"/>
               </a:defRPr>
@@ -4306,7 +4306,7 @@
             <a:pPr>
               <a:defRPr sz="1200">
                 <a:solidFill>
-                  <a:srgbClr val="94A3B8"/>
+                  <a:srgbClr val="142438"/>
                 </a:solidFill>
                 <a:latin typeface="Segoe UI"/>
               </a:defRPr>
@@ -4332,11 +4332,11 @@
             <a:avLst/>
           </a:prstGeom>
           <a:solidFill>
-            <a:srgbClr val="131E32"/>
+            <a:srgbClr val="FFFFFF"/>
           </a:solidFill>
           <a:ln w="15240">
             <a:solidFill>
-              <a:srgbClr val="20304C"/>
+              <a:srgbClr val="08264B"/>
             </a:solidFill>
           </a:ln>
         </p:spPr>
@@ -4364,7 +4364,7 @@
               </a:spcAft>
               <a:defRPr sz="1700" b="1">
                 <a:solidFill>
-                  <a:srgbClr val="90E6FC"/>
+                  <a:srgbClr val="004BA5"/>
                 </a:solidFill>
                 <a:latin typeface="Segoe UI"/>
               </a:defRPr>
@@ -4377,7 +4377,7 @@
             <a:pPr>
               <a:defRPr sz="1200">
                 <a:solidFill>
-                  <a:srgbClr val="94A3B8"/>
+                  <a:srgbClr val="142438"/>
                 </a:solidFill>
                 <a:latin typeface="Segoe UI"/>
               </a:defRPr>
@@ -4403,11 +4403,11 @@
             <a:avLst/>
           </a:prstGeom>
           <a:solidFill>
-            <a:srgbClr val="131E32"/>
+            <a:srgbClr val="FFFFFF"/>
           </a:solidFill>
           <a:ln w="15240">
             <a:solidFill>
-              <a:srgbClr val="20304C"/>
+              <a:srgbClr val="08264B"/>
             </a:solidFill>
           </a:ln>
         </p:spPr>
@@ -4435,7 +4435,7 @@
               </a:spcAft>
               <a:defRPr sz="1700" b="1">
                 <a:solidFill>
-                  <a:srgbClr val="90E6FC"/>
+                  <a:srgbClr val="004BA5"/>
                 </a:solidFill>
                 <a:latin typeface="Segoe UI"/>
               </a:defRPr>
@@ -4448,7 +4448,7 @@
             <a:pPr>
               <a:defRPr sz="1200">
                 <a:solidFill>
-                  <a:srgbClr val="94A3B8"/>
+                  <a:srgbClr val="142438"/>
                 </a:solidFill>
                 <a:latin typeface="Segoe UI"/>
               </a:defRPr>
@@ -4474,11 +4474,11 @@
             <a:avLst/>
           </a:prstGeom>
           <a:solidFill>
-            <a:srgbClr val="131E32"/>
+            <a:srgbClr val="FFFFFF"/>
           </a:solidFill>
           <a:ln w="15240">
             <a:solidFill>
-              <a:srgbClr val="20304C"/>
+              <a:srgbClr val="08264B"/>
             </a:solidFill>
           </a:ln>
         </p:spPr>
@@ -4506,7 +4506,7 @@
               </a:spcAft>
               <a:defRPr sz="1700" b="1">
                 <a:solidFill>
-                  <a:srgbClr val="90E6FC"/>
+                  <a:srgbClr val="004BA5"/>
                 </a:solidFill>
                 <a:latin typeface="Segoe UI"/>
               </a:defRPr>
@@ -4519,7 +4519,7 @@
             <a:pPr>
               <a:defRPr sz="1200">
                 <a:solidFill>
-                  <a:srgbClr val="94A3B8"/>
+                  <a:srgbClr val="142438"/>
                 </a:solidFill>
                 <a:latin typeface="Segoe UI"/>
               </a:defRPr>
@@ -4563,7 +4563,7 @@
             <a:avLst/>
           </a:prstGeom>
           <a:solidFill>
-            <a:srgbClr val="0B111E"/>
+            <a:srgbClr val="00FFFF"/>
           </a:solidFill>
           <a:ln>
             <a:noFill/>
@@ -4600,13 +4600,13 @@
         <p:spPr>
           <a:xfrm>
             <a:off x="0" y="0"/>
-            <a:ext cx="12191695" cy="54864"/>
+            <a:ext cx="12191695" cy="64008"/>
           </a:xfrm>
           <a:prstGeom prst="rect">
             <a:avLst/>
           </a:prstGeom>
           <a:solidFill>
-            <a:srgbClr val="90E6FC"/>
+            <a:srgbClr val="061830"/>
           </a:solidFill>
           <a:ln>
             <a:noFill/>
@@ -4643,7 +4643,7 @@
         <p:spPr>
           <a:xfrm>
             <a:off x="731520" y="320040"/>
-            <a:ext cx="10728655" cy="1005840"/>
+            <a:ext cx="10728655" cy="1051560"/>
           </a:xfrm>
           <a:prstGeom prst="rect">
             <a:avLst/>
@@ -4660,9 +4660,9 @@
               <a:spcAft>
                 <a:spcPts val="200"/>
               </a:spcAft>
-              <a:defRPr sz="1050" b="1">
-                <a:solidFill>
-                  <a:srgbClr val="90E6FC"/>
+              <a:defRPr sz="1100" b="1">
+                <a:solidFill>
+                  <a:srgbClr val="004BA5"/>
                 </a:solidFill>
                 <a:latin typeface="Segoe UI"/>
               </a:defRPr>
@@ -4678,7 +4678,7 @@
               </a:spcAft>
               <a:defRPr sz="2200" b="1">
                 <a:solidFill>
-                  <a:srgbClr val="FFFFFF"/>
+                  <a:srgbClr val="061830"/>
                 </a:solidFill>
                 <a:latin typeface="Segoe UI"/>
               </a:defRPr>
@@ -4691,7 +4691,7 @@
             <a:pPr>
               <a:defRPr sz="1200">
                 <a:solidFill>
-                  <a:srgbClr val="94A3B8"/>
+                  <a:srgbClr val="142438"/>
                 </a:solidFill>
                 <a:latin typeface="Segoe UI"/>
               </a:defRPr>
@@ -4717,11 +4717,11 @@
             <a:avLst/>
           </a:prstGeom>
           <a:solidFill>
-            <a:srgbClr val="131E32"/>
+            <a:srgbClr val="FFFFFF"/>
           </a:solidFill>
           <a:ln w="15240">
             <a:solidFill>
-              <a:srgbClr val="90E6FC"/>
+              <a:srgbClr val="004BA5"/>
             </a:solidFill>
           </a:ln>
         </p:spPr>
@@ -4749,7 +4749,7 @@
               </a:spcAft>
               <a:defRPr sz="1400" b="1">
                 <a:solidFill>
-                  <a:srgbClr val="90E6FC"/>
+                  <a:srgbClr val="004BA5"/>
                 </a:solidFill>
                 <a:latin typeface="Segoe UI"/>
               </a:defRPr>
@@ -4762,7 +4762,7 @@
             <a:pPr>
               <a:defRPr sz="1100">
                 <a:solidFill>
-                  <a:srgbClr val="94A3B8"/>
+                  <a:srgbClr val="142438"/>
                 </a:solidFill>
                 <a:latin typeface="Segoe UI"/>
               </a:defRPr>
@@ -4808,11 +4808,11 @@
             <a:avLst/>
           </a:prstGeom>
           <a:solidFill>
-            <a:srgbClr val="131E32"/>
+            <a:srgbClr val="FFFFFF"/>
           </a:solidFill>
           <a:ln w="15240">
             <a:solidFill>
-              <a:srgbClr val="20304C"/>
+              <a:srgbClr val="08264B"/>
             </a:solidFill>
           </a:ln>
         </p:spPr>
@@ -4840,7 +4840,7 @@
               </a:spcAft>
               <a:defRPr sz="1400" b="1">
                 <a:solidFill>
-                  <a:srgbClr val="FFFFFF"/>
+                  <a:srgbClr val="061830"/>
                 </a:solidFill>
                 <a:latin typeface="Segoe UI"/>
               </a:defRPr>
@@ -4853,7 +4853,7 @@
             <a:pPr>
               <a:defRPr sz="1100">
                 <a:solidFill>
-                  <a:srgbClr val="94A3B8"/>
+                  <a:srgbClr val="142438"/>
                 </a:solidFill>
                 <a:latin typeface="Segoe UI"/>
               </a:defRPr>
@@ -4899,11 +4899,11 @@
             <a:avLst/>
           </a:prstGeom>
           <a:solidFill>
-            <a:srgbClr val="131E32"/>
+            <a:srgbClr val="FFFFFF"/>
           </a:solidFill>
           <a:ln w="15240">
             <a:solidFill>
-              <a:srgbClr val="20304C"/>
+              <a:srgbClr val="08264B"/>
             </a:solidFill>
           </a:ln>
         </p:spPr>
@@ -4931,7 +4931,7 @@
               </a:spcAft>
               <a:defRPr sz="1400" b="1">
                 <a:solidFill>
-                  <a:srgbClr val="FFFFFF"/>
+                  <a:srgbClr val="061830"/>
                 </a:solidFill>
                 <a:latin typeface="Segoe UI"/>
               </a:defRPr>
@@ -4944,7 +4944,7 @@
             <a:pPr>
               <a:defRPr sz="1100">
                 <a:solidFill>
-                  <a:srgbClr val="94A3B8"/>
+                  <a:srgbClr val="142438"/>
                 </a:solidFill>
                 <a:latin typeface="Segoe UI"/>
               </a:defRPr>
@@ -4986,11 +4986,11 @@
             <a:avLst/>
           </a:prstGeom>
           <a:solidFill>
-            <a:srgbClr val="102A41"/>
+            <a:srgbClr val="061830"/>
           </a:solidFill>
           <a:ln w="15240">
             <a:solidFill>
-              <a:srgbClr val="90E6FC"/>
+              <a:srgbClr val="061830"/>
             </a:solidFill>
           </a:ln>
         </p:spPr>
@@ -5015,7 +5015,7 @@
             <a:pPr algn="ctr">
               <a:defRPr sz="1600" b="1">
                 <a:solidFill>
-                  <a:srgbClr val="90E6FC"/>
+                  <a:srgbClr val="00FFFF"/>
                 </a:solidFill>
                 <a:latin typeface="Segoe UI"/>
               </a:defRPr>
@@ -5044,7 +5044,7 @@
             <a:pPr>
               <a:defRPr sz="1050">
                 <a:solidFill>
-                  <a:srgbClr val="50B4D7"/>
+                  <a:srgbClr val="8CE6FA"/>
                 </a:solidFill>
                 <a:latin typeface="Segoe UI"/>
               </a:defRPr>
@@ -5088,7 +5088,7 @@
             <a:avLst/>
           </a:prstGeom>
           <a:solidFill>
-            <a:srgbClr val="0B111E"/>
+            <a:srgbClr val="00FFFF"/>
           </a:solidFill>
           <a:ln>
             <a:noFill/>
@@ -5125,13 +5125,13 @@
         <p:spPr>
           <a:xfrm>
             <a:off x="0" y="0"/>
-            <a:ext cx="12191695" cy="54864"/>
+            <a:ext cx="12191695" cy="64008"/>
           </a:xfrm>
           <a:prstGeom prst="rect">
             <a:avLst/>
           </a:prstGeom>
           <a:solidFill>
-            <a:srgbClr val="90E6FC"/>
+            <a:srgbClr val="061830"/>
           </a:solidFill>
           <a:ln>
             <a:noFill/>
@@ -5168,7 +5168,7 @@
         <p:spPr>
           <a:xfrm>
             <a:off x="731520" y="320040"/>
-            <a:ext cx="10728655" cy="1005840"/>
+            <a:ext cx="10728655" cy="1051560"/>
           </a:xfrm>
           <a:prstGeom prst="rect">
             <a:avLst/>
@@ -5185,9 +5185,9 @@
               <a:spcAft>
                 <a:spcPts val="200"/>
               </a:spcAft>
-              <a:defRPr sz="1050" b="1">
-                <a:solidFill>
-                  <a:srgbClr val="90E6FC"/>
+              <a:defRPr sz="1100" b="1">
+                <a:solidFill>
+                  <a:srgbClr val="004BA5"/>
                 </a:solidFill>
                 <a:latin typeface="Segoe UI"/>
               </a:defRPr>
@@ -5203,7 +5203,7 @@
               </a:spcAft>
               <a:defRPr sz="2200" b="1">
                 <a:solidFill>
-                  <a:srgbClr val="FFFFFF"/>
+                  <a:srgbClr val="061830"/>
                 </a:solidFill>
                 <a:latin typeface="Segoe UI"/>
               </a:defRPr>
@@ -5216,7 +5216,7 @@
             <a:pPr>
               <a:defRPr sz="1200">
                 <a:solidFill>
-                  <a:srgbClr val="94A3B8"/>
+                  <a:srgbClr val="142438"/>
                 </a:solidFill>
                 <a:latin typeface="Segoe UI"/>
               </a:defRPr>
@@ -5242,11 +5242,11 @@
             <a:avLst/>
           </a:prstGeom>
           <a:solidFill>
-            <a:srgbClr val="131E32"/>
+            <a:srgbClr val="FFFFFF"/>
           </a:solidFill>
           <a:ln w="15240">
             <a:solidFill>
-              <a:srgbClr val="FBBF24"/>
+              <a:srgbClr val="AA1414"/>
             </a:solidFill>
           </a:ln>
         </p:spPr>
@@ -5274,7 +5274,7 @@
               </a:spcAft>
               <a:defRPr sz="1600" b="1">
                 <a:solidFill>
-                  <a:srgbClr val="FBBF24"/>
+                  <a:srgbClr val="AA1414"/>
                 </a:solidFill>
                 <a:latin typeface="Segoe UI"/>
               </a:defRPr>
@@ -5287,7 +5287,7 @@
             <a:pPr>
               <a:defRPr sz="1300">
                 <a:solidFill>
-                  <a:srgbClr val="94A3B8"/>
+                  <a:srgbClr val="142438"/>
                 </a:solidFill>
                 <a:latin typeface="Segoe UI"/>
               </a:defRPr>
@@ -5313,11 +5313,11 @@
             <a:avLst/>
           </a:prstGeom>
           <a:solidFill>
-            <a:srgbClr val="131E32"/>
+            <a:srgbClr val="FFFFFF"/>
           </a:solidFill>
           <a:ln w="15240">
             <a:solidFill>
-              <a:srgbClr val="20304C"/>
+              <a:srgbClr val="08264B"/>
             </a:solidFill>
           </a:ln>
         </p:spPr>
@@ -5345,7 +5345,7 @@
               </a:spcAft>
               <a:defRPr sz="1600" b="1">
                 <a:solidFill>
-                  <a:srgbClr val="90E6FC"/>
+                  <a:srgbClr val="004BA5"/>
                 </a:solidFill>
                 <a:latin typeface="Segoe UI"/>
               </a:defRPr>
@@ -5358,7 +5358,7 @@
             <a:pPr>
               <a:defRPr sz="1300">
                 <a:solidFill>
-                  <a:srgbClr val="94A3B8"/>
+                  <a:srgbClr val="142438"/>
                 </a:solidFill>
                 <a:latin typeface="Segoe UI"/>
               </a:defRPr>
@@ -5384,11 +5384,11 @@
             <a:avLst/>
           </a:prstGeom>
           <a:solidFill>
-            <a:srgbClr val="131E32"/>
+            <a:srgbClr val="FFFFFF"/>
           </a:solidFill>
           <a:ln w="15240">
             <a:solidFill>
-              <a:srgbClr val="20304C"/>
+              <a:srgbClr val="08264B"/>
             </a:solidFill>
           </a:ln>
         </p:spPr>
@@ -5416,7 +5416,7 @@
               </a:spcAft>
               <a:defRPr sz="1600" b="1">
                 <a:solidFill>
-                  <a:srgbClr val="FFFFFF"/>
+                  <a:srgbClr val="061830"/>
                 </a:solidFill>
                 <a:latin typeface="Segoe UI"/>
               </a:defRPr>
@@ -5429,7 +5429,7 @@
             <a:pPr>
               <a:defRPr sz="1300">
                 <a:solidFill>
-                  <a:srgbClr val="94A3B8"/>
+                  <a:srgbClr val="142438"/>
                 </a:solidFill>
                 <a:latin typeface="Segoe UI"/>
               </a:defRPr>
@@ -5455,11 +5455,11 @@
             <a:avLst/>
           </a:prstGeom>
           <a:solidFill>
-            <a:srgbClr val="102A41"/>
+            <a:srgbClr val="061830"/>
           </a:solidFill>
           <a:ln w="15240">
             <a:solidFill>
-              <a:srgbClr val="90E6FC"/>
+              <a:srgbClr val="061830"/>
             </a:solidFill>
           </a:ln>
         </p:spPr>
@@ -5484,7 +5484,7 @@
             <a:pPr algn="ctr">
               <a:defRPr sz="1350" b="1">
                 <a:solidFill>
-                  <a:srgbClr val="90E6FC"/>
+                  <a:srgbClr val="00FFFF"/>
                 </a:solidFill>
                 <a:latin typeface="Segoe UI"/>
               </a:defRPr>
@@ -5528,7 +5528,7 @@
             <a:avLst/>
           </a:prstGeom>
           <a:solidFill>
-            <a:srgbClr val="0B111E"/>
+            <a:srgbClr val="00FFFF"/>
           </a:solidFill>
           <a:ln>
             <a:noFill/>
@@ -5565,13 +5565,13 @@
         <p:spPr>
           <a:xfrm>
             <a:off x="0" y="0"/>
-            <a:ext cx="12191695" cy="54864"/>
+            <a:ext cx="12191695" cy="64008"/>
           </a:xfrm>
           <a:prstGeom prst="rect">
             <a:avLst/>
           </a:prstGeom>
           <a:solidFill>
-            <a:srgbClr val="90E6FC"/>
+            <a:srgbClr val="061830"/>
           </a:solidFill>
           <a:ln>
             <a:noFill/>
@@ -5608,7 +5608,7 @@
         <p:spPr>
           <a:xfrm>
             <a:off x="731520" y="320040"/>
-            <a:ext cx="10728655" cy="1005840"/>
+            <a:ext cx="10728655" cy="1051560"/>
           </a:xfrm>
           <a:prstGeom prst="rect">
             <a:avLst/>
@@ -5625,9 +5625,9 @@
               <a:spcAft>
                 <a:spcPts val="200"/>
               </a:spcAft>
-              <a:defRPr sz="1050" b="1">
-                <a:solidFill>
-                  <a:srgbClr val="90E6FC"/>
+              <a:defRPr sz="1100" b="1">
+                <a:solidFill>
+                  <a:srgbClr val="004BA5"/>
                 </a:solidFill>
                 <a:latin typeface="Segoe UI"/>
               </a:defRPr>
@@ -5643,7 +5643,7 @@
               </a:spcAft>
               <a:defRPr sz="2200" b="1">
                 <a:solidFill>
-                  <a:srgbClr val="FFFFFF"/>
+                  <a:srgbClr val="061830"/>
                 </a:solidFill>
                 <a:latin typeface="Segoe UI"/>
               </a:defRPr>
@@ -5656,7 +5656,7 @@
             <a:pPr>
               <a:defRPr sz="1200">
                 <a:solidFill>
-                  <a:srgbClr val="94A3B8"/>
+                  <a:srgbClr val="142438"/>
                 </a:solidFill>
                 <a:latin typeface="Segoe UI"/>
               </a:defRPr>
@@ -5682,11 +5682,11 @@
             <a:avLst/>
           </a:prstGeom>
           <a:solidFill>
-            <a:srgbClr val="131E32"/>
+            <a:srgbClr val="FFFFFF"/>
           </a:solidFill>
           <a:ln w="15240">
             <a:solidFill>
-              <a:srgbClr val="20304C"/>
+              <a:srgbClr val="08264B"/>
             </a:solidFill>
           </a:ln>
         </p:spPr>
@@ -5714,7 +5714,7 @@
               </a:spcAft>
               <a:defRPr sz="1700" b="1">
                 <a:solidFill>
-                  <a:srgbClr val="90E6FC"/>
+                  <a:srgbClr val="004BA5"/>
                 </a:solidFill>
                 <a:latin typeface="Segoe UI"/>
               </a:defRPr>
@@ -5727,7 +5727,7 @@
             <a:pPr>
               <a:defRPr sz="1300">
                 <a:solidFill>
-                  <a:srgbClr val="94A3B8"/>
+                  <a:srgbClr val="142438"/>
                 </a:solidFill>
                 <a:latin typeface="Segoe UI"/>
               </a:defRPr>
@@ -5753,11 +5753,11 @@
             <a:avLst/>
           </a:prstGeom>
           <a:solidFill>
-            <a:srgbClr val="131E32"/>
+            <a:srgbClr val="FFFFFF"/>
           </a:solidFill>
           <a:ln w="15240">
             <a:solidFill>
-              <a:srgbClr val="20304C"/>
+              <a:srgbClr val="08264B"/>
             </a:solidFill>
           </a:ln>
         </p:spPr>
@@ -5785,7 +5785,7 @@
               </a:spcAft>
               <a:defRPr sz="1700" b="1">
                 <a:solidFill>
-                  <a:srgbClr val="90E6FC"/>
+                  <a:srgbClr val="004BA5"/>
                 </a:solidFill>
                 <a:latin typeface="Segoe UI"/>
               </a:defRPr>
@@ -5798,7 +5798,7 @@
             <a:pPr>
               <a:defRPr sz="1300">
                 <a:solidFill>
-                  <a:srgbClr val="94A3B8"/>
+                  <a:srgbClr val="142438"/>
                 </a:solidFill>
                 <a:latin typeface="Segoe UI"/>
               </a:defRPr>
@@ -5824,11 +5824,11 @@
             <a:avLst/>
           </a:prstGeom>
           <a:solidFill>
-            <a:srgbClr val="131E32"/>
+            <a:srgbClr val="FFFFFF"/>
           </a:solidFill>
           <a:ln w="15240">
             <a:solidFill>
-              <a:srgbClr val="20304C"/>
+              <a:srgbClr val="08264B"/>
             </a:solidFill>
           </a:ln>
         </p:spPr>
@@ -5856,7 +5856,7 @@
               </a:spcAft>
               <a:defRPr sz="1700" b="1">
                 <a:solidFill>
-                  <a:srgbClr val="90E6FC"/>
+                  <a:srgbClr val="004BA5"/>
                 </a:solidFill>
                 <a:latin typeface="Segoe UI"/>
               </a:defRPr>
@@ -5869,7 +5869,7 @@
             <a:pPr>
               <a:defRPr sz="1300">
                 <a:solidFill>
-                  <a:srgbClr val="94A3B8"/>
+                  <a:srgbClr val="142438"/>
                 </a:solidFill>
                 <a:latin typeface="Segoe UI"/>
               </a:defRPr>
@@ -5895,11 +5895,11 @@
             <a:avLst/>
           </a:prstGeom>
           <a:solidFill>
-            <a:srgbClr val="131E32"/>
+            <a:srgbClr val="FFFFFF"/>
           </a:solidFill>
           <a:ln w="15240">
             <a:solidFill>
-              <a:srgbClr val="20304C"/>
+              <a:srgbClr val="08264B"/>
             </a:solidFill>
           </a:ln>
         </p:spPr>
@@ -5927,7 +5927,7 @@
               </a:spcAft>
               <a:defRPr sz="1700" b="1">
                 <a:solidFill>
-                  <a:srgbClr val="90E6FC"/>
+                  <a:srgbClr val="004BA5"/>
                 </a:solidFill>
                 <a:latin typeface="Segoe UI"/>
               </a:defRPr>
@@ -5940,7 +5940,7 @@
             <a:pPr>
               <a:defRPr sz="1300">
                 <a:solidFill>
-                  <a:srgbClr val="94A3B8"/>
+                  <a:srgbClr val="142438"/>
                 </a:solidFill>
                 <a:latin typeface="Segoe UI"/>
               </a:defRPr>
@@ -5984,7 +5984,7 @@
             <a:avLst/>
           </a:prstGeom>
           <a:solidFill>
-            <a:srgbClr val="0B111E"/>
+            <a:srgbClr val="00FFFF"/>
           </a:solidFill>
           <a:ln>
             <a:noFill/>
@@ -6021,13 +6021,13 @@
         <p:spPr>
           <a:xfrm>
             <a:off x="0" y="0"/>
-            <a:ext cx="12191695" cy="54864"/>
+            <a:ext cx="12191695" cy="64008"/>
           </a:xfrm>
           <a:prstGeom prst="rect">
             <a:avLst/>
           </a:prstGeom>
           <a:solidFill>
-            <a:srgbClr val="90E6FC"/>
+            <a:srgbClr val="061830"/>
           </a:solidFill>
           <a:ln>
             <a:noFill/>
@@ -6064,7 +6064,7 @@
         <p:spPr>
           <a:xfrm>
             <a:off x="731520" y="320040"/>
-            <a:ext cx="10728655" cy="1005840"/>
+            <a:ext cx="10728655" cy="1051560"/>
           </a:xfrm>
           <a:prstGeom prst="rect">
             <a:avLst/>
@@ -6081,9 +6081,9 @@
               <a:spcAft>
                 <a:spcPts val="200"/>
               </a:spcAft>
-              <a:defRPr sz="1050" b="1">
-                <a:solidFill>
-                  <a:srgbClr val="90E6FC"/>
+              <a:defRPr sz="1100" b="1">
+                <a:solidFill>
+                  <a:srgbClr val="004BA5"/>
                 </a:solidFill>
                 <a:latin typeface="Segoe UI"/>
               </a:defRPr>
@@ -6099,7 +6099,7 @@
               </a:spcAft>
               <a:defRPr sz="2200" b="1">
                 <a:solidFill>
-                  <a:srgbClr val="FFFFFF"/>
+                  <a:srgbClr val="061830"/>
                 </a:solidFill>
                 <a:latin typeface="Segoe UI"/>
               </a:defRPr>
@@ -6112,7 +6112,7 @@
             <a:pPr>
               <a:defRPr sz="1200">
                 <a:solidFill>
-                  <a:srgbClr val="94A3B8"/>
+                  <a:srgbClr val="142438"/>
                 </a:solidFill>
                 <a:latin typeface="Segoe UI"/>
               </a:defRPr>
@@ -6138,11 +6138,11 @@
             <a:avLst/>
           </a:prstGeom>
           <a:solidFill>
-            <a:srgbClr val="131E32"/>
+            <a:srgbClr val="FFFFFF"/>
           </a:solidFill>
           <a:ln w="15240">
             <a:solidFill>
-              <a:srgbClr val="20304C"/>
+              <a:srgbClr val="08264B"/>
             </a:solidFill>
           </a:ln>
         </p:spPr>
@@ -6167,7 +6167,7 @@
             <a:pPr algn="ctr">
               <a:defRPr sz="1300" b="1">
                 <a:solidFill>
-                  <a:srgbClr val="90E6FC"/>
+                  <a:srgbClr val="004BA5"/>
                 </a:solidFill>
                 <a:latin typeface="Segoe UI"/>
               </a:defRPr>
@@ -6180,7 +6180,7 @@
             <a:pPr>
               <a:defRPr sz="1050">
                 <a:solidFill>
-                  <a:srgbClr val="94A3B8"/>
+                  <a:srgbClr val="142438"/>
                 </a:solidFill>
                 <a:latin typeface="Segoe UI"/>
               </a:defRPr>
@@ -6206,11 +6206,11 @@
             <a:avLst/>
           </a:prstGeom>
           <a:solidFill>
-            <a:srgbClr val="131E32"/>
+            <a:srgbClr val="FFFFFF"/>
           </a:solidFill>
           <a:ln w="15240">
             <a:solidFill>
-              <a:srgbClr val="2D5F82"/>
+              <a:srgbClr val="004BA5"/>
             </a:solidFill>
           </a:ln>
         </p:spPr>
@@ -6235,7 +6235,7 @@
             <a:pPr algn="ctr">
               <a:defRPr sz="1300" b="1">
                 <a:solidFill>
-                  <a:srgbClr val="90E6FC"/>
+                  <a:srgbClr val="004BA5"/>
                 </a:solidFill>
                 <a:latin typeface="Segoe UI"/>
               </a:defRPr>
@@ -6248,7 +6248,7 @@
             <a:pPr>
               <a:defRPr sz="1050">
                 <a:solidFill>
-                  <a:srgbClr val="94A3B8"/>
+                  <a:srgbClr val="142438"/>
                 </a:solidFill>
                 <a:latin typeface="Segoe UI"/>
               </a:defRPr>
@@ -6274,11 +6274,11 @@
             <a:avLst/>
           </a:prstGeom>
           <a:solidFill>
-            <a:srgbClr val="131E32"/>
+            <a:srgbClr val="FFFFFF"/>
           </a:solidFill>
           <a:ln w="15240">
             <a:solidFill>
-              <a:srgbClr val="20304C"/>
+              <a:srgbClr val="08264B"/>
             </a:solidFill>
           </a:ln>
         </p:spPr>
@@ -6303,7 +6303,7 @@
             <a:pPr algn="ctr">
               <a:defRPr sz="1300" b="1">
                 <a:solidFill>
-                  <a:srgbClr val="90E6FC"/>
+                  <a:srgbClr val="004BA5"/>
                 </a:solidFill>
                 <a:latin typeface="Segoe UI"/>
               </a:defRPr>
@@ -6316,7 +6316,7 @@
             <a:pPr>
               <a:defRPr sz="1050">
                 <a:solidFill>
-                  <a:srgbClr val="94A3B8"/>
+                  <a:srgbClr val="142438"/>
                 </a:solidFill>
                 <a:latin typeface="Segoe UI"/>
               </a:defRPr>
@@ -6342,11 +6342,11 @@
             <a:avLst/>
           </a:prstGeom>
           <a:solidFill>
-            <a:srgbClr val="131E32"/>
+            <a:srgbClr val="FFFFFF"/>
           </a:solidFill>
           <a:ln w="15240">
             <a:solidFill>
-              <a:srgbClr val="20304C"/>
+              <a:srgbClr val="08264B"/>
             </a:solidFill>
           </a:ln>
         </p:spPr>
@@ -6371,7 +6371,7 @@
             <a:pPr algn="ctr">
               <a:defRPr sz="1300" b="1">
                 <a:solidFill>
-                  <a:srgbClr val="90E6FC"/>
+                  <a:srgbClr val="004BA5"/>
                 </a:solidFill>
                 <a:latin typeface="Segoe UI"/>
               </a:defRPr>
@@ -6384,7 +6384,7 @@
             <a:pPr>
               <a:defRPr sz="1050">
                 <a:solidFill>
-                  <a:srgbClr val="94A3B8"/>
+                  <a:srgbClr val="142438"/>
                 </a:solidFill>
                 <a:latin typeface="Segoe UI"/>
               </a:defRPr>
@@ -6410,11 +6410,11 @@
             <a:avLst/>
           </a:prstGeom>
           <a:solidFill>
-            <a:srgbClr val="131E32"/>
+            <a:srgbClr val="FFFFFF"/>
           </a:solidFill>
           <a:ln w="15240">
             <a:solidFill>
-              <a:srgbClr val="20304C"/>
+              <a:srgbClr val="08264B"/>
             </a:solidFill>
           </a:ln>
         </p:spPr>
@@ -6439,7 +6439,7 @@
             <a:pPr algn="ctr">
               <a:defRPr sz="1300" b="1">
                 <a:solidFill>
-                  <a:srgbClr val="90E6FC"/>
+                  <a:srgbClr val="004BA5"/>
                 </a:solidFill>
                 <a:latin typeface="Segoe UI"/>
               </a:defRPr>
@@ -6452,7 +6452,7 @@
             <a:pPr>
               <a:defRPr sz="1050">
                 <a:solidFill>
-                  <a:srgbClr val="94A3B8"/>
+                  <a:srgbClr val="142438"/>
                 </a:solidFill>
                 <a:latin typeface="Segoe UI"/>
               </a:defRPr>
@@ -6478,11 +6478,11 @@
             <a:avLst/>
           </a:prstGeom>
           <a:solidFill>
-            <a:srgbClr val="0E1727"/>
+            <a:srgbClr val="FFFFFF"/>
           </a:solidFill>
           <a:ln w="15240">
             <a:solidFill>
-              <a:srgbClr val="90E6FC"/>
+              <a:srgbClr val="061830"/>
             </a:solidFill>
           </a:ln>
         </p:spPr>
@@ -6555,9 +6555,9 @@
           <a:lstStyle/>
           <a:p>
             <a:pPr algn="ctr">
-              <a:defRPr sz="1000">
-                <a:solidFill>
-                  <a:srgbClr val="50B4D7"/>
+              <a:defRPr sz="1000" b="1">
+                <a:solidFill>
+                  <a:srgbClr val="061830"/>
                 </a:solidFill>
                 <a:latin typeface="Segoe UI"/>
               </a:defRPr>
@@ -6601,7 +6601,7 @@
             <a:avLst/>
           </a:prstGeom>
           <a:solidFill>
-            <a:srgbClr val="0B111E"/>
+            <a:srgbClr val="00FFFF"/>
           </a:solidFill>
           <a:ln>
             <a:noFill/>
@@ -6638,13 +6638,13 @@
         <p:spPr>
           <a:xfrm>
             <a:off x="0" y="0"/>
-            <a:ext cx="12191695" cy="54864"/>
+            <a:ext cx="12191695" cy="64008"/>
           </a:xfrm>
           <a:prstGeom prst="rect">
             <a:avLst/>
           </a:prstGeom>
           <a:solidFill>
-            <a:srgbClr val="90E6FC"/>
+            <a:srgbClr val="061830"/>
           </a:solidFill>
           <a:ln>
             <a:noFill/>
@@ -6681,7 +6681,7 @@
         <p:spPr>
           <a:xfrm>
             <a:off x="731520" y="320040"/>
-            <a:ext cx="10728655" cy="1005840"/>
+            <a:ext cx="10728655" cy="1051560"/>
           </a:xfrm>
           <a:prstGeom prst="rect">
             <a:avLst/>
@@ -6698,9 +6698,9 @@
               <a:spcAft>
                 <a:spcPts val="200"/>
               </a:spcAft>
-              <a:defRPr sz="1050" b="1">
-                <a:solidFill>
-                  <a:srgbClr val="90E6FC"/>
+              <a:defRPr sz="1100" b="1">
+                <a:solidFill>
+                  <a:srgbClr val="004BA5"/>
                 </a:solidFill>
                 <a:latin typeface="Segoe UI"/>
               </a:defRPr>
@@ -6716,7 +6716,7 @@
               </a:spcAft>
               <a:defRPr sz="2200" b="1">
                 <a:solidFill>
-                  <a:srgbClr val="FFFFFF"/>
+                  <a:srgbClr val="061830"/>
                 </a:solidFill>
                 <a:latin typeface="Segoe UI"/>
               </a:defRPr>
@@ -6729,7 +6729,7 @@
             <a:pPr>
               <a:defRPr sz="1200">
                 <a:solidFill>
-                  <a:srgbClr val="94A3B8"/>
+                  <a:srgbClr val="142438"/>
                 </a:solidFill>
                 <a:latin typeface="Segoe UI"/>
               </a:defRPr>
@@ -6755,11 +6755,11 @@
             <a:avLst/>
           </a:prstGeom>
           <a:solidFill>
-            <a:srgbClr val="131E32"/>
+            <a:srgbClr val="FFFFFF"/>
           </a:solidFill>
           <a:ln w="15240">
             <a:solidFill>
-              <a:srgbClr val="20304C"/>
+              <a:srgbClr val="08264B"/>
             </a:solidFill>
           </a:ln>
         </p:spPr>
@@ -6784,7 +6784,7 @@
             <a:pPr algn="ctr">
               <a:defRPr sz="1400" b="1">
                 <a:solidFill>
-                  <a:srgbClr val="90E6FC"/>
+                  <a:srgbClr val="004BA5"/>
                 </a:solidFill>
                 <a:latin typeface="Segoe UI"/>
               </a:defRPr>
@@ -6797,7 +6797,7 @@
             <a:pPr>
               <a:defRPr sz="1100">
                 <a:solidFill>
-                  <a:srgbClr val="94A3B8"/>
+                  <a:srgbClr val="142438"/>
                 </a:solidFill>
                 <a:latin typeface="Segoe UI"/>
               </a:defRPr>
@@ -6823,11 +6823,11 @@
             <a:avLst/>
           </a:prstGeom>
           <a:solidFill>
-            <a:srgbClr val="131E32"/>
+            <a:srgbClr val="FFFFFF"/>
           </a:solidFill>
           <a:ln w="15240">
             <a:solidFill>
-              <a:srgbClr val="20304C"/>
+              <a:srgbClr val="08264B"/>
             </a:solidFill>
           </a:ln>
         </p:spPr>
@@ -6852,7 +6852,7 @@
             <a:pPr algn="ctr">
               <a:defRPr sz="1400" b="1">
                 <a:solidFill>
-                  <a:srgbClr val="90E6FC"/>
+                  <a:srgbClr val="004BA5"/>
                 </a:solidFill>
                 <a:latin typeface="Segoe UI"/>
               </a:defRPr>
@@ -6865,7 +6865,7 @@
             <a:pPr>
               <a:defRPr sz="1100">
                 <a:solidFill>
-                  <a:srgbClr val="94A3B8"/>
+                  <a:srgbClr val="142438"/>
                 </a:solidFill>
                 <a:latin typeface="Segoe UI"/>
               </a:defRPr>
@@ -6891,11 +6891,11 @@
             <a:avLst/>
           </a:prstGeom>
           <a:solidFill>
-            <a:srgbClr val="131E32"/>
+            <a:srgbClr val="FFFFFF"/>
           </a:solidFill>
           <a:ln w="15240">
             <a:solidFill>
-              <a:srgbClr val="20304C"/>
+              <a:srgbClr val="08264B"/>
             </a:solidFill>
           </a:ln>
         </p:spPr>
@@ -6920,7 +6920,7 @@
             <a:pPr algn="ctr">
               <a:defRPr sz="1400" b="1">
                 <a:solidFill>
-                  <a:srgbClr val="90E6FC"/>
+                  <a:srgbClr val="004BA5"/>
                 </a:solidFill>
                 <a:latin typeface="Segoe UI"/>
               </a:defRPr>
@@ -6933,7 +6933,7 @@
             <a:pPr>
               <a:defRPr sz="1100">
                 <a:solidFill>
-                  <a:srgbClr val="94A3B8"/>
+                  <a:srgbClr val="142438"/>
                 </a:solidFill>
                 <a:latin typeface="Segoe UI"/>
               </a:defRPr>
@@ -6959,11 +6959,11 @@
             <a:avLst/>
           </a:prstGeom>
           <a:solidFill>
-            <a:srgbClr val="131E32"/>
+            <a:srgbClr val="FFFFFF"/>
           </a:solidFill>
           <a:ln w="15240">
             <a:solidFill>
-              <a:srgbClr val="20304C"/>
+              <a:srgbClr val="08264B"/>
             </a:solidFill>
           </a:ln>
         </p:spPr>
@@ -6988,7 +6988,7 @@
             <a:pPr algn="ctr">
               <a:defRPr sz="1400" b="1">
                 <a:solidFill>
-                  <a:srgbClr val="90E6FC"/>
+                  <a:srgbClr val="004BA5"/>
                 </a:solidFill>
                 <a:latin typeface="Segoe UI"/>
               </a:defRPr>
@@ -7001,7 +7001,7 @@
             <a:pPr>
               <a:defRPr sz="1100">
                 <a:solidFill>
-                  <a:srgbClr val="94A3B8"/>
+                  <a:srgbClr val="142438"/>
                 </a:solidFill>
                 <a:latin typeface="Segoe UI"/>
               </a:defRPr>
@@ -7027,11 +7027,11 @@
             <a:avLst/>
           </a:prstGeom>
           <a:solidFill>
-            <a:srgbClr val="0E1727"/>
+            <a:srgbClr val="FFFFFF"/>
           </a:solidFill>
           <a:ln w="15240">
             <a:solidFill>
-              <a:srgbClr val="90E6FC"/>
+              <a:srgbClr val="061830"/>
             </a:solidFill>
           </a:ln>
         </p:spPr>
@@ -7104,9 +7104,9 @@
           <a:lstStyle/>
           <a:p>
             <a:pPr algn="ctr">
-              <a:defRPr sz="1000">
-                <a:solidFill>
-                  <a:srgbClr val="50B4D7"/>
+              <a:defRPr sz="1000" b="1">
+                <a:solidFill>
+                  <a:srgbClr val="061830"/>
                 </a:solidFill>
                 <a:latin typeface="Segoe UI"/>
               </a:defRPr>
@@ -7150,7 +7150,7 @@
             <a:avLst/>
           </a:prstGeom>
           <a:solidFill>
-            <a:srgbClr val="0B111E"/>
+            <a:srgbClr val="00FFFF"/>
           </a:solidFill>
           <a:ln>
             <a:noFill/>
@@ -7187,13 +7187,13 @@
         <p:spPr>
           <a:xfrm>
             <a:off x="0" y="0"/>
-            <a:ext cx="12191695" cy="54864"/>
+            <a:ext cx="12191695" cy="64008"/>
           </a:xfrm>
           <a:prstGeom prst="rect">
             <a:avLst/>
           </a:prstGeom>
           <a:solidFill>
-            <a:srgbClr val="90E6FC"/>
+            <a:srgbClr val="061830"/>
           </a:solidFill>
           <a:ln>
             <a:noFill/>
@@ -7230,7 +7230,7 @@
         <p:spPr>
           <a:xfrm>
             <a:off x="731520" y="320040"/>
-            <a:ext cx="10728655" cy="1005840"/>
+            <a:ext cx="10728655" cy="1051560"/>
           </a:xfrm>
           <a:prstGeom prst="rect">
             <a:avLst/>
@@ -7247,9 +7247,9 @@
               <a:spcAft>
                 <a:spcPts val="200"/>
               </a:spcAft>
-              <a:defRPr sz="1050" b="1">
-                <a:solidFill>
-                  <a:srgbClr val="90E6FC"/>
+              <a:defRPr sz="1100" b="1">
+                <a:solidFill>
+                  <a:srgbClr val="004BA5"/>
                 </a:solidFill>
                 <a:latin typeface="Segoe UI"/>
               </a:defRPr>
@@ -7265,7 +7265,7 @@
               </a:spcAft>
               <a:defRPr sz="2200" b="1">
                 <a:solidFill>
-                  <a:srgbClr val="FFFFFF"/>
+                  <a:srgbClr val="061830"/>
                 </a:solidFill>
                 <a:latin typeface="Segoe UI"/>
               </a:defRPr>
@@ -7278,7 +7278,7 @@
             <a:pPr>
               <a:defRPr sz="1200">
                 <a:solidFill>
-                  <a:srgbClr val="94A3B8"/>
+                  <a:srgbClr val="142438"/>
                 </a:solidFill>
                 <a:latin typeface="Segoe UI"/>
               </a:defRPr>
@@ -7304,11 +7304,11 @@
             <a:avLst/>
           </a:prstGeom>
           <a:solidFill>
-            <a:srgbClr val="131E32"/>
+            <a:srgbClr val="FFFFFF"/>
           </a:solidFill>
           <a:ln w="15240">
             <a:solidFill>
-              <a:srgbClr val="20304C"/>
+              <a:srgbClr val="08264B"/>
             </a:solidFill>
           </a:ln>
         </p:spPr>
@@ -7336,7 +7336,7 @@
               </a:spcAft>
               <a:defRPr sz="1600" b="1">
                 <a:solidFill>
-                  <a:srgbClr val="FBBF24"/>
+                  <a:srgbClr val="AA1414"/>
                 </a:solidFill>
                 <a:latin typeface="Segoe UI"/>
               </a:defRPr>
@@ -7352,7 +7352,7 @@
               </a:spcAft>
               <a:defRPr sz="1150">
                 <a:solidFill>
-                  <a:srgbClr val="94A3B8"/>
+                  <a:srgbClr val="142438"/>
                 </a:solidFill>
                 <a:latin typeface="Segoe UI"/>
               </a:defRPr>
@@ -7369,7 +7369,7 @@
               </a:spcAft>
               <a:defRPr sz="1600" b="1">
                 <a:solidFill>
-                  <a:srgbClr val="90E6FC"/>
+                  <a:srgbClr val="004BA5"/>
                 </a:solidFill>
                 <a:latin typeface="Segoe UI"/>
               </a:defRPr>
@@ -7385,7 +7385,7 @@
               </a:spcAft>
               <a:defRPr sz="1100">
                 <a:solidFill>
-                  <a:srgbClr val="FFFFFF"/>
+                  <a:srgbClr val="061830"/>
                 </a:solidFill>
                 <a:latin typeface="Segoe UI"/>
               </a:defRPr>
@@ -7401,7 +7401,7 @@
               </a:spcAft>
               <a:defRPr sz="1100">
                 <a:solidFill>
-                  <a:srgbClr val="FFFFFF"/>
+                  <a:srgbClr val="061830"/>
                 </a:solidFill>
                 <a:latin typeface="Segoe UI"/>
               </a:defRPr>
@@ -7417,7 +7417,7 @@
               </a:spcAft>
               <a:defRPr sz="1100">
                 <a:solidFill>
-                  <a:srgbClr val="FFFFFF"/>
+                  <a:srgbClr val="061830"/>
                 </a:solidFill>
                 <a:latin typeface="Segoe UI"/>
               </a:defRPr>
@@ -7433,7 +7433,7 @@
               </a:spcAft>
               <a:defRPr sz="1100">
                 <a:solidFill>
-                  <a:srgbClr val="FFFFFF"/>
+                  <a:srgbClr val="061830"/>
                 </a:solidFill>
                 <a:latin typeface="Segoe UI"/>
               </a:defRPr>
@@ -7459,11 +7459,11 @@
             <a:avLst/>
           </a:prstGeom>
           <a:solidFill>
-            <a:srgbClr val="0E1727"/>
+            <a:srgbClr val="FFFFFF"/>
           </a:solidFill>
           <a:ln w="15240">
             <a:solidFill>
-              <a:srgbClr val="90E6FC"/>
+              <a:srgbClr val="061830"/>
             </a:solidFill>
           </a:ln>
         </p:spPr>
@@ -7536,15 +7536,15 @@
           <a:lstStyle/>
           <a:p>
             <a:pPr algn="ctr">
-              <a:defRPr sz="1000">
-                <a:solidFill>
-                  <a:srgbClr val="50B4D7"/>
-                </a:solidFill>
-                <a:latin typeface="Segoe UI"/>
-              </a:defRPr>
-            </a:pPr>
-            <a:r>
-              <a:t>Figure 2: Textract Before/After Split Comparison Showing Pixel-Perfect Background Retention</a:t>
+              <a:defRPr sz="1000" b="1">
+                <a:solidFill>
+                  <a:srgbClr val="061830"/>
+                </a:solidFill>
+                <a:latin typeface="Segoe UI"/>
+              </a:defRPr>
+            </a:pPr>
+            <a:r>
+              <a:t>Figure 3: Textract Before/After Split Comparison Showing Pixel-Perfect Background Retention</a:t>
             </a:r>
           </a:p>
         </p:txBody>
@@ -7582,7 +7582,7 @@
             <a:avLst/>
           </a:prstGeom>
           <a:solidFill>
-            <a:srgbClr val="0B111E"/>
+            <a:srgbClr val="00FFFF"/>
           </a:solidFill>
           <a:ln>
             <a:noFill/>
@@ -7619,13 +7619,13 @@
         <p:spPr>
           <a:xfrm>
             <a:off x="0" y="0"/>
-            <a:ext cx="12191695" cy="54864"/>
+            <a:ext cx="12191695" cy="64008"/>
           </a:xfrm>
           <a:prstGeom prst="rect">
             <a:avLst/>
           </a:prstGeom>
           <a:solidFill>
-            <a:srgbClr val="90E6FC"/>
+            <a:srgbClr val="061830"/>
           </a:solidFill>
           <a:ln>
             <a:noFill/>
@@ -7662,7 +7662,7 @@
         <p:spPr>
           <a:xfrm>
             <a:off x="731520" y="320040"/>
-            <a:ext cx="10728655" cy="1005840"/>
+            <a:ext cx="10728655" cy="1051560"/>
           </a:xfrm>
           <a:prstGeom prst="rect">
             <a:avLst/>
@@ -7679,9 +7679,9 @@
               <a:spcAft>
                 <a:spcPts val="200"/>
               </a:spcAft>
-              <a:defRPr sz="1050" b="1">
-                <a:solidFill>
-                  <a:srgbClr val="90E6FC"/>
+              <a:defRPr sz="1100" b="1">
+                <a:solidFill>
+                  <a:srgbClr val="004BA5"/>
                 </a:solidFill>
                 <a:latin typeface="Segoe UI"/>
               </a:defRPr>
@@ -7697,7 +7697,7 @@
               </a:spcAft>
               <a:defRPr sz="2200" b="1">
                 <a:solidFill>
-                  <a:srgbClr val="FFFFFF"/>
+                  <a:srgbClr val="061830"/>
                 </a:solidFill>
                 <a:latin typeface="Segoe UI"/>
               </a:defRPr>
@@ -7710,7 +7710,7 @@
             <a:pPr>
               <a:defRPr sz="1200">
                 <a:solidFill>
-                  <a:srgbClr val="94A3B8"/>
+                  <a:srgbClr val="142438"/>
                 </a:solidFill>
                 <a:latin typeface="Segoe UI"/>
               </a:defRPr>
@@ -7736,11 +7736,11 @@
             <a:avLst/>
           </a:prstGeom>
           <a:solidFill>
-            <a:srgbClr val="131E32"/>
+            <a:srgbClr val="FFFFFF"/>
           </a:solidFill>
           <a:ln w="15240">
             <a:solidFill>
-              <a:srgbClr val="20304C"/>
+              <a:srgbClr val="08264B"/>
             </a:solidFill>
           </a:ln>
         </p:spPr>
@@ -7768,7 +7768,7 @@
               </a:spcAft>
               <a:defRPr sz="1500" b="1">
                 <a:solidFill>
-                  <a:srgbClr val="90E6FC"/>
+                  <a:srgbClr val="004BA5"/>
                 </a:solidFill>
                 <a:latin typeface="Segoe UI"/>
               </a:defRPr>
@@ -7784,7 +7784,7 @@
               </a:spcAft>
               <a:defRPr sz="1100">
                 <a:solidFill>
-                  <a:srgbClr val="94A3B8"/>
+                  <a:srgbClr val="142438"/>
                 </a:solidFill>
                 <a:latin typeface="Segoe UI"/>
               </a:defRPr>
@@ -7800,7 +7800,7 @@
               </a:spcAft>
               <a:defRPr sz="1500" b="1">
                 <a:solidFill>
-                  <a:srgbClr val="90E6FC"/>
+                  <a:srgbClr val="004BA5"/>
                 </a:solidFill>
                 <a:latin typeface="Segoe UI"/>
               </a:defRPr>
@@ -7816,7 +7816,7 @@
               </a:spcAft>
               <a:defRPr sz="1100">
                 <a:solidFill>
-                  <a:srgbClr val="94A3B8"/>
+                  <a:srgbClr val="142438"/>
                 </a:solidFill>
                 <a:latin typeface="Segoe UI"/>
               </a:defRPr>
@@ -7832,7 +7832,7 @@
               </a:spcAft>
               <a:defRPr sz="1500" b="1">
                 <a:solidFill>
-                  <a:srgbClr val="90E6FC"/>
+                  <a:srgbClr val="004BA5"/>
                 </a:solidFill>
                 <a:latin typeface="Segoe UI"/>
               </a:defRPr>
@@ -7848,7 +7848,7 @@
               </a:spcAft>
               <a:defRPr sz="1100">
                 <a:solidFill>
-                  <a:srgbClr val="94A3B8"/>
+                  <a:srgbClr val="142438"/>
                 </a:solidFill>
                 <a:latin typeface="Segoe UI"/>
               </a:defRPr>
@@ -7864,7 +7864,7 @@
               </a:spcAft>
               <a:defRPr sz="1500" b="1">
                 <a:solidFill>
-                  <a:srgbClr val="90E6FC"/>
+                  <a:srgbClr val="004BA5"/>
                 </a:solidFill>
                 <a:latin typeface="Segoe UI"/>
               </a:defRPr>
@@ -7880,7 +7880,7 @@
               </a:spcAft>
               <a:defRPr sz="1100">
                 <a:solidFill>
-                  <a:srgbClr val="94A3B8"/>
+                  <a:srgbClr val="142438"/>
                 </a:solidFill>
                 <a:latin typeface="Segoe UI"/>
               </a:defRPr>
@@ -7906,11 +7906,11 @@
             <a:avLst/>
           </a:prstGeom>
           <a:solidFill>
-            <a:srgbClr val="0E1727"/>
+            <a:srgbClr val="FFFFFF"/>
           </a:solidFill>
           <a:ln w="15240">
             <a:solidFill>
-              <a:srgbClr val="90E6FC"/>
+              <a:srgbClr val="061830"/>
             </a:solidFill>
           </a:ln>
         </p:spPr>
@@ -7983,15 +7983,15 @@
           <a:lstStyle/>
           <a:p>
             <a:pPr algn="ctr">
-              <a:defRPr sz="1000">
-                <a:solidFill>
-                  <a:srgbClr val="50B4D7"/>
-                </a:solidFill>
-                <a:latin typeface="Segoe UI"/>
-              </a:defRPr>
-            </a:pPr>
-            <a:r>
-              <a:t>Figure 3: 8-Way Interactive Resize Handles &amp; In-Place Inline Editor</a:t>
+              <a:defRPr sz="1000" b="1">
+                <a:solidFill>
+                  <a:srgbClr val="061830"/>
+                </a:solidFill>
+                <a:latin typeface="Segoe UI"/>
+              </a:defRPr>
+            </a:pPr>
+            <a:r>
+              <a:t>Figure 4: 8-Directional Resize Handles &amp; In-Place Inline Editor</a:t>
             </a:r>
           </a:p>
         </p:txBody>
@@ -8029,7 +8029,7 @@
             <a:avLst/>
           </a:prstGeom>
           <a:solidFill>
-            <a:srgbClr val="0B111E"/>
+            <a:srgbClr val="00FFFF"/>
           </a:solidFill>
           <a:ln>
             <a:noFill/>
@@ -8066,13 +8066,13 @@
         <p:spPr>
           <a:xfrm>
             <a:off x="0" y="0"/>
-            <a:ext cx="12191695" cy="54864"/>
+            <a:ext cx="12191695" cy="64008"/>
           </a:xfrm>
           <a:prstGeom prst="rect">
             <a:avLst/>
           </a:prstGeom>
           <a:solidFill>
-            <a:srgbClr val="90E6FC"/>
+            <a:srgbClr val="061830"/>
           </a:solidFill>
           <a:ln>
             <a:noFill/>
@@ -8109,7 +8109,7 @@
         <p:spPr>
           <a:xfrm>
             <a:off x="731520" y="320040"/>
-            <a:ext cx="10728655" cy="1005840"/>
+            <a:ext cx="10728655" cy="1051560"/>
           </a:xfrm>
           <a:prstGeom prst="rect">
             <a:avLst/>
@@ -8126,9 +8126,9 @@
               <a:spcAft>
                 <a:spcPts val="200"/>
               </a:spcAft>
-              <a:defRPr sz="1050" b="1">
-                <a:solidFill>
-                  <a:srgbClr val="90E6FC"/>
+              <a:defRPr sz="1100" b="1">
+                <a:solidFill>
+                  <a:srgbClr val="004BA5"/>
                 </a:solidFill>
                 <a:latin typeface="Segoe UI"/>
               </a:defRPr>
@@ -8144,7 +8144,7 @@
               </a:spcAft>
               <a:defRPr sz="2200" b="1">
                 <a:solidFill>
-                  <a:srgbClr val="FFFFFF"/>
+                  <a:srgbClr val="061830"/>
                 </a:solidFill>
                 <a:latin typeface="Segoe UI"/>
               </a:defRPr>
@@ -8157,7 +8157,7 @@
             <a:pPr>
               <a:defRPr sz="1200">
                 <a:solidFill>
-                  <a:srgbClr val="94A3B8"/>
+                  <a:srgbClr val="142438"/>
                 </a:solidFill>
                 <a:latin typeface="Segoe UI"/>
               </a:defRPr>
@@ -8183,11 +8183,11 @@
             <a:avLst/>
           </a:prstGeom>
           <a:solidFill>
-            <a:srgbClr val="131E32"/>
+            <a:srgbClr val="FFFFFF"/>
           </a:solidFill>
           <a:ln w="15240">
             <a:solidFill>
-              <a:srgbClr val="20304C"/>
+              <a:srgbClr val="08264B"/>
             </a:solidFill>
           </a:ln>
         </p:spPr>
@@ -8215,7 +8215,7 @@
               </a:spcAft>
               <a:defRPr sz="1700" b="1">
                 <a:solidFill>
-                  <a:srgbClr val="90E6FC"/>
+                  <a:srgbClr val="004BA5"/>
                 </a:solidFill>
                 <a:latin typeface="Segoe UI"/>
               </a:defRPr>
@@ -8228,7 +8228,7 @@
             <a:pPr>
               <a:defRPr sz="1200">
                 <a:solidFill>
-                  <a:srgbClr val="94A3B8"/>
+                  <a:srgbClr val="142438"/>
                 </a:solidFill>
                 <a:latin typeface="Segoe UI"/>
               </a:defRPr>
@@ -8258,11 +8258,11 @@
             <a:avLst/>
           </a:prstGeom>
           <a:solidFill>
-            <a:srgbClr val="131E32"/>
+            <a:srgbClr val="FFFFFF"/>
           </a:solidFill>
           <a:ln w="15240">
             <a:solidFill>
-              <a:srgbClr val="20304C"/>
+              <a:srgbClr val="08264B"/>
             </a:solidFill>
           </a:ln>
         </p:spPr>
@@ -8290,7 +8290,7 @@
               </a:spcAft>
               <a:defRPr sz="1700" b="1">
                 <a:solidFill>
-                  <a:srgbClr val="FFFFFF"/>
+                  <a:srgbClr val="061830"/>
                 </a:solidFill>
                 <a:latin typeface="Segoe UI"/>
               </a:defRPr>
@@ -8303,7 +8303,7 @@
             <a:pPr>
               <a:defRPr sz="1200">
                 <a:solidFill>
-                  <a:srgbClr val="94A3B8"/>
+                  <a:srgbClr val="142438"/>
                 </a:solidFill>
                 <a:latin typeface="Segoe UI"/>
               </a:defRPr>
@@ -8329,11 +8329,11 @@
             <a:avLst/>
           </a:prstGeom>
           <a:solidFill>
-            <a:srgbClr val="131E32"/>
+            <a:srgbClr val="FFFFFF"/>
           </a:solidFill>
           <a:ln w="15240">
             <a:solidFill>
-              <a:srgbClr val="20304C"/>
+              <a:srgbClr val="08264B"/>
             </a:solidFill>
           </a:ln>
         </p:spPr>
@@ -8361,7 +8361,7 @@
               </a:spcAft>
               <a:defRPr sz="1700" b="1">
                 <a:solidFill>
-                  <a:srgbClr val="90E6FC"/>
+                  <a:srgbClr val="004BA5"/>
                 </a:solidFill>
                 <a:latin typeface="Segoe UI"/>
               </a:defRPr>
@@ -8374,7 +8374,7 @@
             <a:pPr>
               <a:defRPr sz="1200">
                 <a:solidFill>
-                  <a:srgbClr val="94A3B8"/>
+                  <a:srgbClr val="142438"/>
                 </a:solidFill>
                 <a:latin typeface="Segoe UI"/>
               </a:defRPr>
@@ -8400,11 +8400,11 @@
             <a:avLst/>
           </a:prstGeom>
           <a:solidFill>
-            <a:srgbClr val="131E32"/>
+            <a:srgbClr val="FFFFFF"/>
           </a:solidFill>
           <a:ln w="15240">
             <a:solidFill>
-              <a:srgbClr val="20304C"/>
+              <a:srgbClr val="08264B"/>
             </a:solidFill>
           </a:ln>
         </p:spPr>
@@ -8432,7 +8432,7 @@
               </a:spcAft>
               <a:defRPr sz="1700" b="1">
                 <a:solidFill>
-                  <a:srgbClr val="FFFFFF"/>
+                  <a:srgbClr val="061830"/>
                 </a:solidFill>
                 <a:latin typeface="Segoe UI"/>
               </a:defRPr>
@@ -8445,7 +8445,7 @@
             <a:pPr>
               <a:defRPr sz="1200">
                 <a:solidFill>
-                  <a:srgbClr val="94A3B8"/>
+                  <a:srgbClr val="142438"/>
                 </a:solidFill>
                 <a:latin typeface="Segoe UI"/>
               </a:defRPr>
@@ -8493,7 +8493,7 @@
             <a:avLst/>
           </a:prstGeom>
           <a:solidFill>
-            <a:srgbClr val="0B111E"/>
+            <a:srgbClr val="00FFFF"/>
           </a:solidFill>
           <a:ln>
             <a:noFill/>
@@ -8530,13 +8530,13 @@
         <p:spPr>
           <a:xfrm>
             <a:off x="0" y="0"/>
-            <a:ext cx="12191695" cy="54864"/>
+            <a:ext cx="12191695" cy="64008"/>
           </a:xfrm>
           <a:prstGeom prst="rect">
             <a:avLst/>
           </a:prstGeom>
           <a:solidFill>
-            <a:srgbClr val="90E6FC"/>
+            <a:srgbClr val="061830"/>
           </a:solidFill>
           <a:ln>
             <a:noFill/>
@@ -8573,7 +8573,7 @@
         <p:spPr>
           <a:xfrm>
             <a:off x="731520" y="320040"/>
-            <a:ext cx="10728655" cy="1005840"/>
+            <a:ext cx="10728655" cy="1051560"/>
           </a:xfrm>
           <a:prstGeom prst="rect">
             <a:avLst/>
@@ -8590,9 +8590,9 @@
               <a:spcAft>
                 <a:spcPts val="200"/>
               </a:spcAft>
-              <a:defRPr sz="1050" b="1">
-                <a:solidFill>
-                  <a:srgbClr val="90E6FC"/>
+              <a:defRPr sz="1100" b="1">
+                <a:solidFill>
+                  <a:srgbClr val="004BA5"/>
                 </a:solidFill>
                 <a:latin typeface="Segoe UI"/>
               </a:defRPr>
@@ -8608,7 +8608,7 @@
               </a:spcAft>
               <a:defRPr sz="2200" b="1">
                 <a:solidFill>
-                  <a:srgbClr val="FFFFFF"/>
+                  <a:srgbClr val="061830"/>
                 </a:solidFill>
                 <a:latin typeface="Segoe UI"/>
               </a:defRPr>
@@ -8621,7 +8621,7 @@
             <a:pPr>
               <a:defRPr sz="1200">
                 <a:solidFill>
-                  <a:srgbClr val="94A3B8"/>
+                  <a:srgbClr val="142438"/>
                 </a:solidFill>
                 <a:latin typeface="Segoe UI"/>
               </a:defRPr>
@@ -8677,7 +8677,7 @@
                   </a:txBody>
                   <a:tcPr>
                     <a:solidFill>
-                      <a:srgbClr val="101A2C"/>
+                      <a:srgbClr val="061830"/>
                     </a:solidFill>
                   </a:tcPr>
                 </a:tc>
@@ -8701,7 +8701,7 @@
                   </a:txBody>
                   <a:tcPr>
                     <a:solidFill>
-                      <a:srgbClr val="101A2C"/>
+                      <a:srgbClr val="061830"/>
                     </a:solidFill>
                   </a:tcPr>
                 </a:tc>
@@ -8725,7 +8725,7 @@
                   </a:txBody>
                   <a:tcPr>
                     <a:solidFill>
-                      <a:srgbClr val="101A2C"/>
+                      <a:srgbClr val="061830"/>
                     </a:solidFill>
                   </a:tcPr>
                 </a:tc>
@@ -8737,7 +8737,7 @@
                       <a:pPr algn="ctr">
                         <a:defRPr sz="1250" b="1">
                           <a:solidFill>
-                            <a:srgbClr val="90E6FC"/>
+                            <a:srgbClr val="00FFFF"/>
                           </a:solidFill>
                           <a:latin typeface="Segoe UI"/>
                         </a:defRPr>
@@ -8749,7 +8749,7 @@
                   </a:txBody>
                   <a:tcPr>
                     <a:solidFill>
-                      <a:srgbClr val="102A41"/>
+                      <a:srgbClr val="004BA5"/>
                     </a:solidFill>
                   </a:tcPr>
                 </a:tc>
@@ -8763,7 +8763,7 @@
                       <a:pPr>
                         <a:defRPr sz="1150" b="1">
                           <a:solidFill>
-                            <a:srgbClr val="FFFFFF"/>
+                            <a:srgbClr val="061830"/>
                           </a:solidFill>
                           <a:latin typeface="Segoe UI"/>
                         </a:defRPr>
@@ -8775,7 +8775,7 @@
                   </a:txBody>
                   <a:tcPr>
                     <a:solidFill>
-                      <a:srgbClr val="131E32"/>
+                      <a:srgbClr val="FFFFFF"/>
                     </a:solidFill>
                   </a:tcPr>
                 </a:tc>
@@ -8787,7 +8787,7 @@
                       <a:pPr algn="ctr">
                         <a:defRPr sz="1150">
                           <a:solidFill>
-                            <a:srgbClr val="94A3B8"/>
+                            <a:srgbClr val="142438"/>
                           </a:solidFill>
                           <a:latin typeface="Segoe UI"/>
                         </a:defRPr>
@@ -8799,7 +8799,7 @@
                   </a:txBody>
                   <a:tcPr>
                     <a:solidFill>
-                      <a:srgbClr val="131E32"/>
+                      <a:srgbClr val="FFFFFF"/>
                     </a:solidFill>
                   </a:tcPr>
                 </a:tc>
@@ -8811,7 +8811,7 @@
                       <a:pPr algn="ctr">
                         <a:defRPr sz="1150">
                           <a:solidFill>
-                            <a:srgbClr val="94A3B8"/>
+                            <a:srgbClr val="142438"/>
                           </a:solidFill>
                           <a:latin typeface="Segoe UI"/>
                         </a:defRPr>
@@ -8823,7 +8823,7 @@
                   </a:txBody>
                   <a:tcPr>
                     <a:solidFill>
-                      <a:srgbClr val="131E32"/>
+                      <a:srgbClr val="FFFFFF"/>
                     </a:solidFill>
                   </a:tcPr>
                 </a:tc>
@@ -8835,7 +8835,7 @@
                       <a:pPr algn="ctr">
                         <a:defRPr sz="1150" b="1">
                           <a:solidFill>
-                            <a:srgbClr val="34D399"/>
+                            <a:srgbClr val="0A7D41"/>
                           </a:solidFill>
                           <a:latin typeface="Segoe UI"/>
                         </a:defRPr>
@@ -8847,7 +8847,7 @@
                   </a:txBody>
                   <a:tcPr>
                     <a:solidFill>
-                      <a:srgbClr val="12263E"/>
+                      <a:srgbClr val="C6F5FF"/>
                     </a:solidFill>
                   </a:tcPr>
                 </a:tc>
@@ -8861,7 +8861,7 @@
                       <a:pPr>
                         <a:defRPr sz="1150" b="1">
                           <a:solidFill>
-                            <a:srgbClr val="FFFFFF"/>
+                            <a:srgbClr val="061830"/>
                           </a:solidFill>
                           <a:latin typeface="Segoe UI"/>
                         </a:defRPr>
@@ -8873,7 +8873,7 @@
                   </a:txBody>
                   <a:tcPr>
                     <a:solidFill>
-                      <a:srgbClr val="0F1726"/>
+                      <a:srgbClr val="E4FCFF"/>
                     </a:solidFill>
                   </a:tcPr>
                 </a:tc>
@@ -8885,7 +8885,7 @@
                       <a:pPr algn="ctr">
                         <a:defRPr sz="1150">
                           <a:solidFill>
-                            <a:srgbClr val="94A3B8"/>
+                            <a:srgbClr val="142438"/>
                           </a:solidFill>
                           <a:latin typeface="Segoe UI"/>
                         </a:defRPr>
@@ -8897,7 +8897,7 @@
                   </a:txBody>
                   <a:tcPr>
                     <a:solidFill>
-                      <a:srgbClr val="0F1726"/>
+                      <a:srgbClr val="E4FCFF"/>
                     </a:solidFill>
                   </a:tcPr>
                 </a:tc>
@@ -8909,7 +8909,7 @@
                       <a:pPr algn="ctr">
                         <a:defRPr sz="1150">
                           <a:solidFill>
-                            <a:srgbClr val="94A3B8"/>
+                            <a:srgbClr val="142438"/>
                           </a:solidFill>
                           <a:latin typeface="Segoe UI"/>
                         </a:defRPr>
@@ -8921,7 +8921,7 @@
                   </a:txBody>
                   <a:tcPr>
                     <a:solidFill>
-                      <a:srgbClr val="0F1726"/>
+                      <a:srgbClr val="E4FCFF"/>
                     </a:solidFill>
                   </a:tcPr>
                 </a:tc>
@@ -8933,7 +8933,7 @@
                       <a:pPr algn="ctr">
                         <a:defRPr sz="1150" b="1">
                           <a:solidFill>
-                            <a:srgbClr val="34D399"/>
+                            <a:srgbClr val="0A7D41"/>
                           </a:solidFill>
                           <a:latin typeface="Segoe UI"/>
                         </a:defRPr>
@@ -8945,7 +8945,7 @@
                   </a:txBody>
                   <a:tcPr>
                     <a:solidFill>
-                      <a:srgbClr val="12263E"/>
+                      <a:srgbClr val="C6F5FF"/>
                     </a:solidFill>
                   </a:tcPr>
                 </a:tc>
@@ -8959,7 +8959,7 @@
                       <a:pPr>
                         <a:defRPr sz="1150" b="1">
                           <a:solidFill>
-                            <a:srgbClr val="FFFFFF"/>
+                            <a:srgbClr val="061830"/>
                           </a:solidFill>
                           <a:latin typeface="Segoe UI"/>
                         </a:defRPr>
@@ -8971,7 +8971,7 @@
                   </a:txBody>
                   <a:tcPr>
                     <a:solidFill>
-                      <a:srgbClr val="131E32"/>
+                      <a:srgbClr val="FFFFFF"/>
                     </a:solidFill>
                   </a:tcPr>
                 </a:tc>
@@ -8983,7 +8983,7 @@
                       <a:pPr algn="ctr">
                         <a:defRPr sz="1150">
                           <a:solidFill>
-                            <a:srgbClr val="94A3B8"/>
+                            <a:srgbClr val="142438"/>
                           </a:solidFill>
                           <a:latin typeface="Segoe UI"/>
                         </a:defRPr>
@@ -8995,7 +8995,7 @@
                   </a:txBody>
                   <a:tcPr>
                     <a:solidFill>
-                      <a:srgbClr val="131E32"/>
+                      <a:srgbClr val="FFFFFF"/>
                     </a:solidFill>
                   </a:tcPr>
                 </a:tc>
@@ -9007,7 +9007,7 @@
                       <a:pPr algn="ctr">
                         <a:defRPr sz="1150">
                           <a:solidFill>
-                            <a:srgbClr val="94A3B8"/>
+                            <a:srgbClr val="142438"/>
                           </a:solidFill>
                           <a:latin typeface="Segoe UI"/>
                         </a:defRPr>
@@ -9019,7 +9019,7 @@
                   </a:txBody>
                   <a:tcPr>
                     <a:solidFill>
-                      <a:srgbClr val="131E32"/>
+                      <a:srgbClr val="FFFFFF"/>
                     </a:solidFill>
                   </a:tcPr>
                 </a:tc>
@@ -9031,7 +9031,7 @@
                       <a:pPr algn="ctr">
                         <a:defRPr sz="1150" b="1">
                           <a:solidFill>
-                            <a:srgbClr val="34D399"/>
+                            <a:srgbClr val="0A7D41"/>
                           </a:solidFill>
                           <a:latin typeface="Segoe UI"/>
                         </a:defRPr>
@@ -9043,7 +9043,7 @@
                   </a:txBody>
                   <a:tcPr>
                     <a:solidFill>
-                      <a:srgbClr val="12263E"/>
+                      <a:srgbClr val="C6F5FF"/>
                     </a:solidFill>
                   </a:tcPr>
                 </a:tc>
@@ -9057,7 +9057,7 @@
                       <a:pPr>
                         <a:defRPr sz="1150" b="1">
                           <a:solidFill>
-                            <a:srgbClr val="FFFFFF"/>
+                            <a:srgbClr val="061830"/>
                           </a:solidFill>
                           <a:latin typeface="Segoe UI"/>
                         </a:defRPr>
@@ -9069,7 +9069,7 @@
                   </a:txBody>
                   <a:tcPr>
                     <a:solidFill>
-                      <a:srgbClr val="0F1726"/>
+                      <a:srgbClr val="E4FCFF"/>
                     </a:solidFill>
                   </a:tcPr>
                 </a:tc>
@@ -9081,7 +9081,7 @@
                       <a:pPr algn="ctr">
                         <a:defRPr sz="1150">
                           <a:solidFill>
-                            <a:srgbClr val="94A3B8"/>
+                            <a:srgbClr val="142438"/>
                           </a:solidFill>
                           <a:latin typeface="Segoe UI"/>
                         </a:defRPr>
@@ -9093,7 +9093,7 @@
                   </a:txBody>
                   <a:tcPr>
                     <a:solidFill>
-                      <a:srgbClr val="0F1726"/>
+                      <a:srgbClr val="E4FCFF"/>
                     </a:solidFill>
                   </a:tcPr>
                 </a:tc>
@@ -9105,7 +9105,7 @@
                       <a:pPr algn="ctr">
                         <a:defRPr sz="1150">
                           <a:solidFill>
-                            <a:srgbClr val="94A3B8"/>
+                            <a:srgbClr val="142438"/>
                           </a:solidFill>
                           <a:latin typeface="Segoe UI"/>
                         </a:defRPr>
@@ -9117,7 +9117,7 @@
                   </a:txBody>
                   <a:tcPr>
                     <a:solidFill>
-                      <a:srgbClr val="0F1726"/>
+                      <a:srgbClr val="E4FCFF"/>
                     </a:solidFill>
                   </a:tcPr>
                 </a:tc>
@@ -9129,7 +9129,7 @@
                       <a:pPr algn="ctr">
                         <a:defRPr sz="1150" b="1">
                           <a:solidFill>
-                            <a:srgbClr val="34D399"/>
+                            <a:srgbClr val="0A7D41"/>
                           </a:solidFill>
                           <a:latin typeface="Segoe UI"/>
                         </a:defRPr>
@@ -9141,7 +9141,7 @@
                   </a:txBody>
                   <a:tcPr>
                     <a:solidFill>
-                      <a:srgbClr val="12263E"/>
+                      <a:srgbClr val="C6F5FF"/>
                     </a:solidFill>
                   </a:tcPr>
                 </a:tc>
@@ -9155,7 +9155,7 @@
                       <a:pPr>
                         <a:defRPr sz="1150" b="1">
                           <a:solidFill>
-                            <a:srgbClr val="FFFFFF"/>
+                            <a:srgbClr val="061830"/>
                           </a:solidFill>
                           <a:latin typeface="Segoe UI"/>
                         </a:defRPr>
@@ -9167,7 +9167,7 @@
                   </a:txBody>
                   <a:tcPr>
                     <a:solidFill>
-                      <a:srgbClr val="131E32"/>
+                      <a:srgbClr val="FFFFFF"/>
                     </a:solidFill>
                   </a:tcPr>
                 </a:tc>
@@ -9179,7 +9179,7 @@
                       <a:pPr algn="ctr">
                         <a:defRPr sz="1150">
                           <a:solidFill>
-                            <a:srgbClr val="94A3B8"/>
+                            <a:srgbClr val="142438"/>
                           </a:solidFill>
                           <a:latin typeface="Segoe UI"/>
                         </a:defRPr>
@@ -9191,7 +9191,7 @@
                   </a:txBody>
                   <a:tcPr>
                     <a:solidFill>
-                      <a:srgbClr val="131E32"/>
+                      <a:srgbClr val="FFFFFF"/>
                     </a:solidFill>
                   </a:tcPr>
                 </a:tc>
@@ -9203,7 +9203,7 @@
                       <a:pPr algn="ctr">
                         <a:defRPr sz="1150">
                           <a:solidFill>
-                            <a:srgbClr val="94A3B8"/>
+                            <a:srgbClr val="142438"/>
                           </a:solidFill>
                           <a:latin typeface="Segoe UI"/>
                         </a:defRPr>
@@ -9215,7 +9215,7 @@
                   </a:txBody>
                   <a:tcPr>
                     <a:solidFill>
-                      <a:srgbClr val="131E32"/>
+                      <a:srgbClr val="FFFFFF"/>
                     </a:solidFill>
                   </a:tcPr>
                 </a:tc>
@@ -9227,7 +9227,7 @@
                       <a:pPr algn="ctr">
                         <a:defRPr sz="1150" b="1">
                           <a:solidFill>
-                            <a:srgbClr val="90E6FC"/>
+                            <a:srgbClr val="004BA5"/>
                           </a:solidFill>
                           <a:latin typeface="Segoe UI"/>
                         </a:defRPr>
@@ -9239,7 +9239,7 @@
                   </a:txBody>
                   <a:tcPr>
                     <a:solidFill>
-                      <a:srgbClr val="12263E"/>
+                      <a:srgbClr val="C6F5FF"/>
                     </a:solidFill>
                   </a:tcPr>
                 </a:tc>
@@ -9253,7 +9253,7 @@
                       <a:pPr>
                         <a:defRPr sz="1150" b="1">
                           <a:solidFill>
-                            <a:srgbClr val="FFFFFF"/>
+                            <a:srgbClr val="061830"/>
                           </a:solidFill>
                           <a:latin typeface="Segoe UI"/>
                         </a:defRPr>
@@ -9265,7 +9265,7 @@
                   </a:txBody>
                   <a:tcPr>
                     <a:solidFill>
-                      <a:srgbClr val="0F1726"/>
+                      <a:srgbClr val="E4FCFF"/>
                     </a:solidFill>
                   </a:tcPr>
                 </a:tc>
@@ -9277,7 +9277,7 @@
                       <a:pPr algn="ctr">
                         <a:defRPr sz="1150">
                           <a:solidFill>
-                            <a:srgbClr val="94A3B8"/>
+                            <a:srgbClr val="142438"/>
                           </a:solidFill>
                           <a:latin typeface="Segoe UI"/>
                         </a:defRPr>
@@ -9289,7 +9289,7 @@
                   </a:txBody>
                   <a:tcPr>
                     <a:solidFill>
-                      <a:srgbClr val="0F1726"/>
+                      <a:srgbClr val="E4FCFF"/>
                     </a:solidFill>
                   </a:tcPr>
                 </a:tc>
@@ -9301,7 +9301,7 @@
                       <a:pPr algn="ctr">
                         <a:defRPr sz="1150">
                           <a:solidFill>
-                            <a:srgbClr val="94A3B8"/>
+                            <a:srgbClr val="142438"/>
                           </a:solidFill>
                           <a:latin typeface="Segoe UI"/>
                         </a:defRPr>
@@ -9313,7 +9313,7 @@
                   </a:txBody>
                   <a:tcPr>
                     <a:solidFill>
-                      <a:srgbClr val="0F1726"/>
+                      <a:srgbClr val="E4FCFF"/>
                     </a:solidFill>
                   </a:tcPr>
                 </a:tc>
@@ -9325,7 +9325,7 @@
                       <a:pPr algn="ctr">
                         <a:defRPr sz="1150" b="1">
                           <a:solidFill>
-                            <a:srgbClr val="34D399"/>
+                            <a:srgbClr val="0A7D41"/>
                           </a:solidFill>
                           <a:latin typeface="Segoe UI"/>
                         </a:defRPr>
@@ -9337,7 +9337,7 @@
                   </a:txBody>
                   <a:tcPr>
                     <a:solidFill>
-                      <a:srgbClr val="12263E"/>
+                      <a:srgbClr val="C6F5FF"/>
                     </a:solidFill>
                   </a:tcPr>
                 </a:tc>
@@ -9361,11 +9361,11 @@
             <a:avLst/>
           </a:prstGeom>
           <a:solidFill>
-            <a:srgbClr val="101A2C"/>
+            <a:srgbClr val="061830"/>
           </a:solidFill>
           <a:ln w="15240">
             <a:solidFill>
-              <a:srgbClr val="2D5F82"/>
+              <a:srgbClr val="061830"/>
             </a:solidFill>
           </a:ln>
         </p:spPr>
@@ -9390,7 +9390,7 @@
             <a:pPr algn="ctr">
               <a:defRPr sz="1150" b="1">
                 <a:solidFill>
-                  <a:srgbClr val="90E6FC"/>
+                  <a:srgbClr val="00FFFF"/>
                 </a:solidFill>
                 <a:latin typeface="Segoe UI"/>
               </a:defRPr>

</xml_diff>